<commit_message>
fix(presentation): real subscripts via XML + redesign math slides without arrows
Subscripts on slides previously used Unicode characters (APₛ, APₗ).
PowerPoint with Helvetica substitutes the font and renders these as
empty boxes on many systems. Replaced every such usage with run-level
XML baseline shift via a new add_runs() helper — font-independent.

Math slides redesigned: dropped the arrow-to-variable annotations
(positions were not landing on the right symbols) in favor of a
center-equation + colored Q/K/V (or m/g/t) cards layout. The card
colors match what the equation symbols carry visually, and there is
no fragile pixel-targeting of arrows.

Future-work slide rewritten with explicit How / Goal lines per
direction (training-only P2, lighter P2, distillation), matching
the refined framing in the paper's Limitations section.
</commit_message>
<xml_diff>
--- a/presentation/feedback_rtdetr_presentation.pptx
+++ b/presentation/feedback_rtdetr_presentation.pptx
@@ -3632,7 +3632,7 @@
         <p:spPr>
           <a:xfrm>
             <a:off x="457200" y="1371600"/>
-            <a:ext cx="11247120" cy="5011823"/>
+            <a:ext cx="11247120" cy="4875472"/>
           </a:xfrm>
           <a:prstGeom prst="rect">
             <a:avLst/>
@@ -3848,8 +3848,8 @@
         </p:nvSpPr>
         <p:spPr>
           <a:xfrm>
-            <a:off x="640080" y="2377440"/>
-            <a:ext cx="5120640" cy="1828800"/>
+            <a:off x="365760" y="2560320"/>
+            <a:ext cx="5852160" cy="1463040"/>
           </a:xfrm>
           <a:prstGeom prst="rect">
             <a:avLst/>
@@ -3864,13 +3864,31 @@
           <a:p>
             <a:pPr algn="ctr"/>
             <a:r>
-              <a:rPr sz="7200" b="1" i="0">
+              <a:rPr sz="5600" b="1" i="0">
                 <a:solidFill>
                   <a:srgbClr val="D62C2E"/>
                 </a:solidFill>
                 <a:latin typeface="Helvetica"/>
               </a:rPr>
-              <a:t>Δ APₛ  =  0.00</a:t>
+              <a:t>Δ AP</a:t>
+            </a:r>
+            <a:r>
+              <a:rPr sz="5600" b="1" i="0" baseline="-25000">
+                <a:solidFill>
+                  <a:srgbClr val="D62C2E"/>
+                </a:solidFill>
+                <a:latin typeface="Helvetica"/>
+              </a:rPr>
+              <a:t>S</a:t>
+            </a:r>
+            <a:r>
+              <a:rPr sz="5600" b="1" i="0">
+                <a:solidFill>
+                  <a:srgbClr val="D62C2E"/>
+                </a:solidFill>
+                <a:latin typeface="Helvetica"/>
+              </a:rPr>
+              <a:t>  =  0.00</a:t>
             </a:r>
           </a:p>
         </p:txBody>
@@ -3883,8 +3901,8 @@
         </p:nvSpPr>
         <p:spPr>
           <a:xfrm>
-            <a:off x="640080" y="4206240"/>
-            <a:ext cx="5120640" cy="457200"/>
+            <a:off x="365760" y="4114800"/>
+            <a:ext cx="5852160" cy="457200"/>
           </a:xfrm>
           <a:prstGeom prst="rect">
             <a:avLst/>
@@ -4719,7 +4737,61 @@
                 </a:solidFill>
                 <a:latin typeface="Helvetica"/>
               </a:rPr>
-              <a:t>AP, APₛ, APₘ, APₗ  —  IoU 0.5..0.95</a:t>
+              <a:t>AP, AP</a:t>
+            </a:r>
+            <a:r>
+              <a:rPr sz="1300" b="0" i="0" baseline="-25000">
+                <a:solidFill>
+                  <a:srgbClr val="1A1A2E"/>
+                </a:solidFill>
+                <a:latin typeface="Helvetica"/>
+              </a:rPr>
+              <a:t>S</a:t>
+            </a:r>
+            <a:r>
+              <a:rPr sz="1300" b="0" i="0">
+                <a:solidFill>
+                  <a:srgbClr val="1A1A2E"/>
+                </a:solidFill>
+                <a:latin typeface="Helvetica"/>
+              </a:rPr>
+              <a:t>, AP</a:t>
+            </a:r>
+            <a:r>
+              <a:rPr sz="1300" b="0" i="0" baseline="-25000">
+                <a:solidFill>
+                  <a:srgbClr val="1A1A2E"/>
+                </a:solidFill>
+                <a:latin typeface="Helvetica"/>
+              </a:rPr>
+              <a:t>M</a:t>
+            </a:r>
+            <a:r>
+              <a:rPr sz="1300" b="0" i="0">
+                <a:solidFill>
+                  <a:srgbClr val="1A1A2E"/>
+                </a:solidFill>
+                <a:latin typeface="Helvetica"/>
+              </a:rPr>
+              <a:t>, AP</a:t>
+            </a:r>
+            <a:r>
+              <a:rPr sz="1300" b="0" i="0" baseline="-25000">
+                <a:solidFill>
+                  <a:srgbClr val="1A1A2E"/>
+                </a:solidFill>
+                <a:latin typeface="Helvetica"/>
+              </a:rPr>
+              <a:t>L</a:t>
+            </a:r>
+            <a:r>
+              <a:rPr sz="1300" b="0" i="0">
+                <a:solidFill>
+                  <a:srgbClr val="1A1A2E"/>
+                </a:solidFill>
+                <a:latin typeface="Helvetica"/>
+              </a:rPr>
+              <a:t>  —  IoU 0.5..0.95</a:t>
             </a:r>
           </a:p>
         </p:txBody>
@@ -4754,7 +4826,25 @@
                 </a:solidFill>
                 <a:latin typeface="Helvetica"/>
               </a:rPr>
-              <a:t>APₛ is the headline metric (area &lt; 32² px)</a:t>
+              <a:t>AP</a:t>
+            </a:r>
+            <a:r>
+              <a:rPr sz="1300" b="1" i="0" baseline="-25000">
+                <a:solidFill>
+                  <a:srgbClr val="1A1A2E"/>
+                </a:solidFill>
+                <a:latin typeface="Helvetica"/>
+              </a:rPr>
+              <a:t>S</a:t>
+            </a:r>
+            <a:r>
+              <a:rPr sz="1300" b="1" i="0">
+                <a:solidFill>
+                  <a:srgbClr val="1A1A2E"/>
+                </a:solidFill>
+                <a:latin typeface="Helvetica"/>
+              </a:rPr>
+              <a:t> is the headline metric (area &lt; 32² px)</a:t>
             </a:r>
           </a:p>
         </p:txBody>
@@ -5847,7 +5937,16 @@
                 </a:solidFill>
                 <a:latin typeface="Helvetica"/>
               </a:rPr>
-              <a:t>APₛ</a:t>
+              <a:t>AP</a:t>
+            </a:r>
+            <a:r>
+              <a:rPr sz="1800" b="0" i="1" baseline="-25000">
+                <a:solidFill>
+                  <a:srgbClr val="666677"/>
+                </a:solidFill>
+                <a:latin typeface="Helvetica"/>
+              </a:rPr>
+              <a:t>S</a:t>
             </a:r>
           </a:p>
         </p:txBody>
@@ -5998,7 +6097,25 @@
                 </a:solidFill>
                 <a:latin typeface="Helvetica"/>
               </a:rPr>
-              <a:t>APₛ    +0.4</a:t>
+              <a:t>AP</a:t>
+            </a:r>
+            <a:r>
+              <a:rPr sz="1800" b="0" i="1" baseline="-25000">
+                <a:solidFill>
+                  <a:srgbClr val="2CA02C"/>
+                </a:solidFill>
+                <a:latin typeface="Helvetica"/>
+              </a:rPr>
+              <a:t>S</a:t>
+            </a:r>
+            <a:r>
+              <a:rPr sz="1800" b="0" i="1">
+                <a:solidFill>
+                  <a:srgbClr val="2CA02C"/>
+                </a:solidFill>
+                <a:latin typeface="Helvetica"/>
+              </a:rPr>
+              <a:t>    +0.4</a:t>
             </a:r>
           </a:p>
         </p:txBody>
@@ -7451,7 +7568,7 @@
                 </a:solidFill>
                 <a:latin typeface="Helvetica"/>
               </a:rPr>
-              <a:t>•  Causal contribution: +0.99 APₛ on the same checkpoint.</a:t>
+              <a:t>•  Causal contribution: +0.99 on small-object AP, same checkpoint.</a:t>
             </a:r>
           </a:p>
         </p:txBody>
@@ -7521,7 +7638,7 @@
                 </a:solidFill>
                 <a:latin typeface="Helvetica"/>
               </a:rPr>
-              <a:t>•  Consistent improvement on every metric (AP, APₛ, APₘ, APₗ).</a:t>
+              <a:t>•  Consistent improvement on every metric (AP, S, M, L).</a:t>
             </a:r>
           </a:p>
         </p:txBody>
@@ -7556,7 +7673,7 @@
                 </a:solidFill>
                 <a:latin typeface="Helvetica"/>
               </a:rPr>
-              <a:t>•  Robust at higher resolution (37.01 APₛ at 800×800).</a:t>
+              <a:t>•  Robust at higher resolution (37.01 small-object AP at 800×800).</a:t>
             </a:r>
           </a:p>
         </p:txBody>
@@ -8027,7 +8144,7 @@
         <p:spPr>
           <a:xfrm>
             <a:off x="640080" y="2194560"/>
-            <a:ext cx="3657600" cy="3474720"/>
+            <a:ext cx="3657600" cy="3657600"/>
           </a:xfrm>
           <a:prstGeom prst="roundRect">
             <a:avLst/>
@@ -8150,8 +8267,8 @@
         </p:nvSpPr>
         <p:spPr>
           <a:xfrm>
-            <a:off x="1417320" y="2377440"/>
-            <a:ext cx="2743200" cy="457200"/>
+            <a:off x="1417320" y="2331720"/>
+            <a:ext cx="2743200" cy="548640"/>
           </a:xfrm>
           <a:prstGeom prst="rect">
             <a:avLst/>
@@ -8166,13 +8283,13 @@
           <a:p>
             <a:pPr algn="l"/>
             <a:r>
-              <a:rPr sz="1500" b="1" i="0">
+              <a:rPr sz="1400" b="1" i="0">
                 <a:solidFill>
                   <a:srgbClr val="1A1A2E"/>
                 </a:solidFill>
                 <a:latin typeface="Helvetica"/>
               </a:rPr>
-              <a:t>Drop P2 at inference</a:t>
+              <a:t>Train with P2, infer without</a:t>
             </a:r>
           </a:p>
         </p:txBody>
@@ -8185,7 +8302,7 @@
         </p:nvSpPr>
         <p:spPr>
           <a:xfrm>
-            <a:off x="822960" y="2926080"/>
+            <a:off x="822960" y="2971800"/>
             <a:ext cx="3291840" cy="365760"/>
           </a:xfrm>
           <a:prstGeom prst="rect">
@@ -8220,8 +8337,8 @@
         </p:nvSpPr>
         <p:spPr>
           <a:xfrm>
-            <a:off x="822960" y="3383280"/>
-            <a:ext cx="3291840" cy="2011680"/>
+            <a:off x="822960" y="3429000"/>
+            <a:ext cx="3291840" cy="365760"/>
           </a:xfrm>
           <a:prstGeom prst="rect">
             <a:avLst/>
@@ -8236,28 +8353,132 @@
           <a:p>
             <a:pPr algn="l"/>
             <a:r>
-              <a:rPr sz="1200" b="0" i="0">
+              <a:rPr sz="1100" b="1" i="0">
+                <a:solidFill>
+                  <a:srgbClr val="1F6FEB"/>
+                </a:solidFill>
+                <a:latin typeface="Helvetica"/>
+              </a:rPr>
+              <a:t>How</a:t>
+            </a:r>
+          </a:p>
+        </p:txBody>
+      </p:sp>
+      <p:sp>
+        <p:nvSpPr>
+          <p:cNvPr id="11" name="TextBox 10"/>
+          <p:cNvSpPr txBox="1"/>
+          <p:nvPr/>
+        </p:nvSpPr>
+        <p:spPr>
+          <a:xfrm>
+            <a:off x="822960" y="3749039"/>
+            <a:ext cx="3291840" cy="1280160"/>
+          </a:xfrm>
+          <a:prstGeom prst="rect">
+            <a:avLst/>
+          </a:prstGeom>
+          <a:noFill/>
+        </p:spPr>
+        <p:txBody>
+          <a:bodyPr wrap="square" lIns="0" rIns="0" tIns="0" bIns="0" anchor="t">
+            <a:spAutoFit/>
+          </a:bodyPr>
+          <a:lstStyle/>
+          <a:p>
+            <a:pPr algn="l"/>
+            <a:r>
+              <a:rPr sz="1100" b="0" i="0">
                 <a:solidFill>
                   <a:srgbClr val="1A1A2E"/>
                 </a:solidFill>
                 <a:latin typeface="Helvetica"/>
               </a:rPr>
-              <a:t>Test whether the +0.99 transfers to the original 3-level (P3–P5) setup.
-If it does → recover ~53 FPS at no accuracy cost.</a:t>
-            </a:r>
-          </a:p>
-        </p:txBody>
-      </p:sp>
-      <p:sp>
-        <p:nvSpPr>
-          <p:cNvPr id="11" name="Rounded Rectangle 10"/>
+              <a:t>Use P2 during training to improve small-object learning, then remove it at inference.</a:t>
+            </a:r>
+          </a:p>
+        </p:txBody>
+      </p:sp>
+      <p:sp>
+        <p:nvSpPr>
+          <p:cNvPr id="12" name="TextBox 11"/>
+          <p:cNvSpPr txBox="1"/>
+          <p:nvPr/>
+        </p:nvSpPr>
+        <p:spPr>
+          <a:xfrm>
+            <a:off x="822960" y="4846320"/>
+            <a:ext cx="3291840" cy="365760"/>
+          </a:xfrm>
+          <a:prstGeom prst="rect">
+            <a:avLst/>
+          </a:prstGeom>
+          <a:noFill/>
+        </p:spPr>
+        <p:txBody>
+          <a:bodyPr wrap="square" lIns="0" rIns="0" tIns="0" bIns="0" anchor="t">
+            <a:spAutoFit/>
+          </a:bodyPr>
+          <a:lstStyle/>
+          <a:p>
+            <a:pPr algn="l"/>
+            <a:r>
+              <a:rPr sz="1100" b="1" i="0">
+                <a:solidFill>
+                  <a:srgbClr val="2CA02C"/>
+                </a:solidFill>
+                <a:latin typeface="Helvetica"/>
+              </a:rPr>
+              <a:t>Goal</a:t>
+            </a:r>
+          </a:p>
+        </p:txBody>
+      </p:sp>
+      <p:sp>
+        <p:nvSpPr>
+          <p:cNvPr id="13" name="TextBox 12"/>
+          <p:cNvSpPr txBox="1"/>
+          <p:nvPr/>
+        </p:nvSpPr>
+        <p:spPr>
+          <a:xfrm>
+            <a:off x="822960" y="5166360"/>
+            <a:ext cx="3291840" cy="1280160"/>
+          </a:xfrm>
+          <a:prstGeom prst="rect">
+            <a:avLst/>
+          </a:prstGeom>
+          <a:noFill/>
+        </p:spPr>
+        <p:txBody>
+          <a:bodyPr wrap="square" lIns="0" rIns="0" tIns="0" bIns="0" anchor="t">
+            <a:spAutoFit/>
+          </a:bodyPr>
+          <a:lstStyle/>
+          <a:p>
+            <a:pPr algn="l"/>
+            <a:r>
+              <a:rPr sz="1100" b="0" i="0">
+                <a:solidFill>
+                  <a:srgbClr val="1A1A2E"/>
+                </a:solidFill>
+                <a:latin typeface="Helvetica"/>
+              </a:rPr>
+              <a:t>Keep most of the +0.99 small-object AP gain without the P2 computational cost.</a:t>
+            </a:r>
+          </a:p>
+        </p:txBody>
+      </p:sp>
+      <p:sp>
+        <p:nvSpPr>
+          <p:cNvPr id="14" name="Rounded Rectangle 13"/>
           <p:cNvSpPr/>
           <p:nvPr/>
         </p:nvSpPr>
         <p:spPr>
           <a:xfrm>
             <a:off x="4434840" y="2194560"/>
-            <a:ext cx="3657600" cy="3474720"/>
+            <a:ext cx="3657600" cy="3657600"/>
           </a:xfrm>
           <a:prstGeom prst="roundRect">
             <a:avLst/>
@@ -8296,7 +8517,7 @@
       </p:sp>
       <p:sp>
         <p:nvSpPr>
-          <p:cNvPr id="12" name="Oval 11"/>
+          <p:cNvPr id="15" name="Oval 14"/>
           <p:cNvSpPr/>
           <p:nvPr/>
         </p:nvSpPr>
@@ -8339,7 +8560,7 @@
       </p:sp>
       <p:sp>
         <p:nvSpPr>
-          <p:cNvPr id="13" name="TextBox 12"/>
+          <p:cNvPr id="16" name="TextBox 15"/>
           <p:cNvSpPr txBox="1"/>
           <p:nvPr/>
         </p:nvSpPr>
@@ -8374,14 +8595,14 @@
       </p:sp>
       <p:sp>
         <p:nvSpPr>
-          <p:cNvPr id="14" name="TextBox 13"/>
-          <p:cNvSpPr txBox="1"/>
-          <p:nvPr/>
-        </p:nvSpPr>
-        <p:spPr>
-          <a:xfrm>
-            <a:off x="5212080" y="2377440"/>
-            <a:ext cx="2743200" cy="457200"/>
+          <p:cNvPr id="17" name="TextBox 16"/>
+          <p:cNvSpPr txBox="1"/>
+          <p:nvPr/>
+        </p:nvSpPr>
+        <p:spPr>
+          <a:xfrm>
+            <a:off x="5212080" y="2331720"/>
+            <a:ext cx="2743200" cy="548640"/>
           </a:xfrm>
           <a:prstGeom prst="rect">
             <a:avLst/>
@@ -8396,7 +8617,7 @@
           <a:p>
             <a:pPr algn="l"/>
             <a:r>
-              <a:rPr sz="1500" b="1" i="0">
+              <a:rPr sz="1400" b="1" i="0">
                 <a:solidFill>
                   <a:srgbClr val="1A1A2E"/>
                 </a:solidFill>
@@ -8409,13 +8630,13 @@
       </p:sp>
       <p:sp>
         <p:nvSpPr>
-          <p:cNvPr id="15" name="TextBox 14"/>
-          <p:cNvSpPr txBox="1"/>
-          <p:nvPr/>
-        </p:nvSpPr>
-        <p:spPr>
-          <a:xfrm>
-            <a:off x="4617720" y="2926080"/>
+          <p:cNvPr id="18" name="TextBox 17"/>
+          <p:cNvSpPr txBox="1"/>
+          <p:nvPr/>
+        </p:nvSpPr>
+        <p:spPr>
+          <a:xfrm>
+            <a:off x="4617720" y="2971800"/>
             <a:ext cx="3291840" cy="365760"/>
           </a:xfrm>
           <a:prstGeom prst="rect">
@@ -8444,14 +8665,14 @@
       </p:sp>
       <p:sp>
         <p:nvSpPr>
-          <p:cNvPr id="16" name="TextBox 15"/>
-          <p:cNvSpPr txBox="1"/>
-          <p:nvPr/>
-        </p:nvSpPr>
-        <p:spPr>
-          <a:xfrm>
-            <a:off x="4617720" y="3383280"/>
-            <a:ext cx="3291840" cy="2011680"/>
+          <p:cNvPr id="19" name="TextBox 18"/>
+          <p:cNvSpPr txBox="1"/>
+          <p:nvPr/>
+        </p:nvSpPr>
+        <p:spPr>
+          <a:xfrm>
+            <a:off x="4617720" y="3429000"/>
+            <a:ext cx="3291840" cy="365760"/>
           </a:xfrm>
           <a:prstGeom prst="rect">
             <a:avLst/>
@@ -8466,28 +8687,132 @@
           <a:p>
             <a:pPr algn="l"/>
             <a:r>
-              <a:rPr sz="1200" b="0" i="0">
+              <a:rPr sz="1100" b="1" i="0">
+                <a:solidFill>
+                  <a:srgbClr val="1F6FEB"/>
+                </a:solidFill>
+                <a:latin typeface="Helvetica"/>
+              </a:rPr>
+              <a:t>How</a:t>
+            </a:r>
+          </a:p>
+        </p:txBody>
+      </p:sp>
+      <p:sp>
+        <p:nvSpPr>
+          <p:cNvPr id="20" name="TextBox 19"/>
+          <p:cNvSpPr txBox="1"/>
+          <p:nvPr/>
+        </p:nvSpPr>
+        <p:spPr>
+          <a:xfrm>
+            <a:off x="4617720" y="3749039"/>
+            <a:ext cx="3291840" cy="1280160"/>
+          </a:xfrm>
+          <a:prstGeom prst="rect">
+            <a:avLst/>
+          </a:prstGeom>
+          <a:noFill/>
+        </p:spPr>
+        <p:txBody>
+          <a:bodyPr wrap="square" lIns="0" rIns="0" tIns="0" bIns="0" anchor="t">
+            <a:spAutoFit/>
+          </a:bodyPr>
+          <a:lstStyle/>
+          <a:p>
+            <a:pPr algn="l"/>
+            <a:r>
+              <a:rPr sz="1100" b="0" i="0">
                 <a:solidFill>
                   <a:srgbClr val="1A1A2E"/>
                 </a:solidFill>
                 <a:latin typeface="Helvetica"/>
               </a:rPr>
-              <a:t>Halve P2 channels; or use a single-conv projection instead of
-the full input-projection block.</a:t>
-            </a:r>
-          </a:p>
-        </p:txBody>
-      </p:sp>
-      <p:sp>
-        <p:nvSpPr>
-          <p:cNvPr id="17" name="Rounded Rectangle 16"/>
+              <a:t>Reduce the cost of P2 — fewer channels, or a simpler projection layer.</a:t>
+            </a:r>
+          </a:p>
+        </p:txBody>
+      </p:sp>
+      <p:sp>
+        <p:nvSpPr>
+          <p:cNvPr id="21" name="TextBox 20"/>
+          <p:cNvSpPr txBox="1"/>
+          <p:nvPr/>
+        </p:nvSpPr>
+        <p:spPr>
+          <a:xfrm>
+            <a:off x="4617720" y="4846320"/>
+            <a:ext cx="3291840" cy="365760"/>
+          </a:xfrm>
+          <a:prstGeom prst="rect">
+            <a:avLst/>
+          </a:prstGeom>
+          <a:noFill/>
+        </p:spPr>
+        <p:txBody>
+          <a:bodyPr wrap="square" lIns="0" rIns="0" tIns="0" bIns="0" anchor="t">
+            <a:spAutoFit/>
+          </a:bodyPr>
+          <a:lstStyle/>
+          <a:p>
+            <a:pPr algn="l"/>
+            <a:r>
+              <a:rPr sz="1100" b="1" i="0">
+                <a:solidFill>
+                  <a:srgbClr val="2CA02C"/>
+                </a:solidFill>
+                <a:latin typeface="Helvetica"/>
+              </a:rPr>
+              <a:t>Goal</a:t>
+            </a:r>
+          </a:p>
+        </p:txBody>
+      </p:sp>
+      <p:sp>
+        <p:nvSpPr>
+          <p:cNvPr id="22" name="TextBox 21"/>
+          <p:cNvSpPr txBox="1"/>
+          <p:nvPr/>
+        </p:nvSpPr>
+        <p:spPr>
+          <a:xfrm>
+            <a:off x="4617720" y="5166360"/>
+            <a:ext cx="3291840" cy="1280160"/>
+          </a:xfrm>
+          <a:prstGeom prst="rect">
+            <a:avLst/>
+          </a:prstGeom>
+          <a:noFill/>
+        </p:spPr>
+        <p:txBody>
+          <a:bodyPr wrap="square" lIns="0" rIns="0" tIns="0" bIns="0" anchor="t">
+            <a:spAutoFit/>
+          </a:bodyPr>
+          <a:lstStyle/>
+          <a:p>
+            <a:pPr algn="l"/>
+            <a:r>
+              <a:rPr sz="1100" b="0" i="0">
+                <a:solidFill>
+                  <a:srgbClr val="1A1A2E"/>
+                </a:solidFill>
+                <a:latin typeface="Helvetica"/>
+              </a:rPr>
+              <a:t>Preserve small-object improvements while reducing the high-resolution P2 slowdown.</a:t>
+            </a:r>
+          </a:p>
+        </p:txBody>
+      </p:sp>
+      <p:sp>
+        <p:nvSpPr>
+          <p:cNvPr id="23" name="Rounded Rectangle 22"/>
           <p:cNvSpPr/>
           <p:nvPr/>
         </p:nvSpPr>
         <p:spPr>
           <a:xfrm>
             <a:off x="8229600" y="2194560"/>
-            <a:ext cx="3657600" cy="3474720"/>
+            <a:ext cx="3657600" cy="3657600"/>
           </a:xfrm>
           <a:prstGeom prst="roundRect">
             <a:avLst/>
@@ -8526,7 +8851,7 @@
       </p:sp>
       <p:sp>
         <p:nvSpPr>
-          <p:cNvPr id="18" name="Oval 17"/>
+          <p:cNvPr id="24" name="Oval 23"/>
           <p:cNvSpPr/>
           <p:nvPr/>
         </p:nvSpPr>
@@ -8569,7 +8894,7 @@
       </p:sp>
       <p:sp>
         <p:nvSpPr>
-          <p:cNvPr id="19" name="TextBox 18"/>
+          <p:cNvPr id="25" name="TextBox 24"/>
           <p:cNvSpPr txBox="1"/>
           <p:nvPr/>
         </p:nvSpPr>
@@ -8604,14 +8929,14 @@
       </p:sp>
       <p:sp>
         <p:nvSpPr>
-          <p:cNvPr id="20" name="TextBox 19"/>
-          <p:cNvSpPr txBox="1"/>
-          <p:nvPr/>
-        </p:nvSpPr>
-        <p:spPr>
-          <a:xfrm>
-            <a:off x="9006840" y="2377440"/>
-            <a:ext cx="2743200" cy="457200"/>
+          <p:cNvPr id="26" name="TextBox 25"/>
+          <p:cNvSpPr txBox="1"/>
+          <p:nvPr/>
+        </p:nvSpPr>
+        <p:spPr>
+          <a:xfrm>
+            <a:off x="9006840" y="2331720"/>
+            <a:ext cx="2743200" cy="548640"/>
           </a:xfrm>
           <a:prstGeom prst="rect">
             <a:avLst/>
@@ -8626,26 +8951,26 @@
           <a:p>
             <a:pPr algn="l"/>
             <a:r>
-              <a:rPr sz="1500" b="1" i="0">
+              <a:rPr sz="1400" b="1" i="0">
                 <a:solidFill>
                   <a:srgbClr val="1A1A2E"/>
                 </a:solidFill>
                 <a:latin typeface="Helvetica"/>
               </a:rPr>
-              <a:t>Distill v2 → student</a:t>
-            </a:r>
-          </a:p>
-        </p:txBody>
-      </p:sp>
-      <p:sp>
-        <p:nvSpPr>
-          <p:cNvPr id="21" name="TextBox 20"/>
-          <p:cNvSpPr txBox="1"/>
-          <p:nvPr/>
-        </p:nvSpPr>
-        <p:spPr>
-          <a:xfrm>
-            <a:off x="8412480" y="2926080"/>
+              <a:t>Knowledge distillation</a:t>
+            </a:r>
+          </a:p>
+        </p:txBody>
+      </p:sp>
+      <p:sp>
+        <p:nvSpPr>
+          <p:cNvPr id="27" name="TextBox 26"/>
+          <p:cNvSpPr txBox="1"/>
+          <p:nvPr/>
+        </p:nvSpPr>
+        <p:spPr>
+          <a:xfrm>
+            <a:off x="8412480" y="2971800"/>
             <a:ext cx="3291840" cy="365760"/>
           </a:xfrm>
           <a:prstGeom prst="rect">
@@ -8674,14 +8999,14 @@
       </p:sp>
       <p:sp>
         <p:nvSpPr>
-          <p:cNvPr id="22" name="TextBox 21"/>
-          <p:cNvSpPr txBox="1"/>
-          <p:nvPr/>
-        </p:nvSpPr>
-        <p:spPr>
-          <a:xfrm>
-            <a:off x="8412480" y="3383280"/>
-            <a:ext cx="3291840" cy="2011680"/>
+          <p:cNvPr id="28" name="TextBox 27"/>
+          <p:cNvSpPr txBox="1"/>
+          <p:nvPr/>
+        </p:nvSpPr>
+        <p:spPr>
+          <a:xfrm>
+            <a:off x="8412480" y="3429000"/>
+            <a:ext cx="3291840" cy="365760"/>
           </a:xfrm>
           <a:prstGeom prst="rect">
             <a:avLst/>
@@ -8696,28 +9021,132 @@
           <a:p>
             <a:pPr algn="l"/>
             <a:r>
-              <a:rPr sz="1200" b="0" i="0">
+              <a:rPr sz="1100" b="1" i="0">
+                <a:solidFill>
+                  <a:srgbClr val="1F6FEB"/>
+                </a:solidFill>
+                <a:latin typeface="Helvetica"/>
+              </a:rPr>
+              <a:t>How</a:t>
+            </a:r>
+          </a:p>
+        </p:txBody>
+      </p:sp>
+      <p:sp>
+        <p:nvSpPr>
+          <p:cNvPr id="29" name="TextBox 28"/>
+          <p:cNvSpPr txBox="1"/>
+          <p:nvPr/>
+        </p:nvSpPr>
+        <p:spPr>
+          <a:xfrm>
+            <a:off x="8412480" y="3749039"/>
+            <a:ext cx="3291840" cy="1280160"/>
+          </a:xfrm>
+          <a:prstGeom prst="rect">
+            <a:avLst/>
+          </a:prstGeom>
+          <a:noFill/>
+        </p:spPr>
+        <p:txBody>
+          <a:bodyPr wrap="square" lIns="0" rIns="0" tIns="0" bIns="0" anchor="t">
+            <a:spAutoFit/>
+          </a:bodyPr>
+          <a:lstStyle/>
+          <a:p>
+            <a:pPr algn="l"/>
+            <a:r>
+              <a:rPr sz="1100" b="0" i="0">
                 <a:solidFill>
                   <a:srgbClr val="1A1A2E"/>
                 </a:solidFill>
                 <a:latin typeface="Helvetica"/>
               </a:rPr>
-              <a:t>Knowledge-distil into a P3–P5 student network.
-Teacher: full v2.  Student: baseline RT-DETR speed.</a:t>
-            </a:r>
-          </a:p>
-        </p:txBody>
-      </p:sp>
-      <p:sp>
-        <p:nvSpPr>
-          <p:cNvPr id="23" name="TextBox 22"/>
-          <p:cNvSpPr txBox="1"/>
-          <p:nvPr/>
-        </p:nvSpPr>
-        <p:spPr>
-          <a:xfrm>
-            <a:off x="640080" y="5943600"/>
-            <a:ext cx="10972800" cy="457200"/>
+              <a:t>Transfer v2's small-object improvements into a faster baseline RT-DETR student.</a:t>
+            </a:r>
+          </a:p>
+        </p:txBody>
+      </p:sp>
+      <p:sp>
+        <p:nvSpPr>
+          <p:cNvPr id="30" name="TextBox 29"/>
+          <p:cNvSpPr txBox="1"/>
+          <p:nvPr/>
+        </p:nvSpPr>
+        <p:spPr>
+          <a:xfrm>
+            <a:off x="8412480" y="4846320"/>
+            <a:ext cx="3291840" cy="365760"/>
+          </a:xfrm>
+          <a:prstGeom prst="rect">
+            <a:avLst/>
+          </a:prstGeom>
+          <a:noFill/>
+        </p:spPr>
+        <p:txBody>
+          <a:bodyPr wrap="square" lIns="0" rIns="0" tIns="0" bIns="0" anchor="t">
+            <a:spAutoFit/>
+          </a:bodyPr>
+          <a:lstStyle/>
+          <a:p>
+            <a:pPr algn="l"/>
+            <a:r>
+              <a:rPr sz="1100" b="1" i="0">
+                <a:solidFill>
+                  <a:srgbClr val="2CA02C"/>
+                </a:solidFill>
+                <a:latin typeface="Helvetica"/>
+              </a:rPr>
+              <a:t>Goal</a:t>
+            </a:r>
+          </a:p>
+        </p:txBody>
+      </p:sp>
+      <p:sp>
+        <p:nvSpPr>
+          <p:cNvPr id="31" name="TextBox 30"/>
+          <p:cNvSpPr txBox="1"/>
+          <p:nvPr/>
+        </p:nvSpPr>
+        <p:spPr>
+          <a:xfrm>
+            <a:off x="8412480" y="5166360"/>
+            <a:ext cx="3291840" cy="1280160"/>
+          </a:xfrm>
+          <a:prstGeom prst="rect">
+            <a:avLst/>
+          </a:prstGeom>
+          <a:noFill/>
+        </p:spPr>
+        <p:txBody>
+          <a:bodyPr wrap="square" lIns="0" rIns="0" tIns="0" bIns="0" anchor="t">
+            <a:spAutoFit/>
+          </a:bodyPr>
+          <a:lstStyle/>
+          <a:p>
+            <a:pPr algn="l"/>
+            <a:r>
+              <a:rPr sz="1100" b="0" i="0">
+                <a:solidFill>
+                  <a:srgbClr val="1A1A2E"/>
+                </a:solidFill>
+                <a:latin typeface="Helvetica"/>
+              </a:rPr>
+              <a:t>Recover baseline inference speed while retaining the small-object AP gains learned from P2 feedback.</a:t>
+            </a:r>
+          </a:p>
+        </p:txBody>
+      </p:sp>
+      <p:sp>
+        <p:nvSpPr>
+          <p:cNvPr id="32" name="TextBox 31"/>
+          <p:cNvSpPr txBox="1"/>
+          <p:nvPr/>
+        </p:nvSpPr>
+        <p:spPr>
+          <a:xfrm>
+            <a:off x="640080" y="6126480"/>
+            <a:ext cx="10972800" cy="365760"/>
           </a:xfrm>
           <a:prstGeom prst="rect">
             <a:avLst/>
@@ -8732,20 +9161,20 @@
           <a:p>
             <a:pPr algn="ctr"/>
             <a:r>
-              <a:rPr sz="1400" b="1" i="0">
+              <a:rPr sz="1300" b="1" i="0">
                 <a:solidFill>
                   <a:srgbClr val="1F6FEB"/>
                 </a:solidFill>
                 <a:latin typeface="Helvetica"/>
               </a:rPr>
-              <a:t>Goal: keep the +0.99 APₛ gain while approaching the 53 FPS baseline.</a:t>
-            </a:r>
-          </a:p>
-        </p:txBody>
-      </p:sp>
-      <p:sp>
-        <p:nvSpPr>
-          <p:cNvPr id="24" name="TextBox 23"/>
+              <a:t>Common goal: keep the +0.99 small-object AP gain while approaching the 53 FPS baseline.</a:t>
+            </a:r>
+          </a:p>
+        </p:txBody>
+      </p:sp>
+      <p:sp>
+        <p:nvSpPr>
+          <p:cNvPr id="33" name="TextBox 32"/>
           <p:cNvSpPr txBox="1"/>
           <p:nvPr/>
         </p:nvSpPr>
@@ -8780,7 +9209,7 @@
       </p:sp>
       <p:sp>
         <p:nvSpPr>
-          <p:cNvPr id="25" name="TextBox 24"/>
+          <p:cNvPr id="34" name="TextBox 33"/>
           <p:cNvSpPr txBox="1"/>
           <p:nvPr/>
         </p:nvSpPr>
@@ -9052,7 +9481,7 @@
                 </a:solidFill>
                 <a:latin typeface="Helvetica"/>
               </a:rPr>
-              <a:t>+0.99 APₛ causal contribution at inference.</a:t>
+              <a:t>+0.99 small-object AP, causal contribution at inference.</a:t>
             </a:r>
           </a:p>
         </p:txBody>
@@ -9774,7 +10203,25 @@
                 </a:solidFill>
                 <a:latin typeface="Helvetica"/>
               </a:rPr>
-              <a:t>APₗ (large)</a:t>
+              <a:t>AP</a:t>
+            </a:r>
+            <a:r>
+              <a:rPr sz="1500" b="0" i="0" baseline="-25000">
+                <a:solidFill>
+                  <a:srgbClr val="666677"/>
+                </a:solidFill>
+                <a:latin typeface="Helvetica"/>
+              </a:rPr>
+              <a:t>L</a:t>
+            </a:r>
+            <a:r>
+              <a:rPr sz="1500" b="0" i="0">
+                <a:solidFill>
+                  <a:srgbClr val="666677"/>
+                </a:solidFill>
+                <a:latin typeface="Helvetica"/>
+              </a:rPr>
+              <a:t> (large)</a:t>
             </a:r>
           </a:p>
         </p:txBody>
@@ -9844,7 +10291,25 @@
                 </a:solidFill>
                 <a:latin typeface="Helvetica"/>
               </a:rPr>
-              <a:t>APₛ (small)</a:t>
+              <a:t>AP</a:t>
+            </a:r>
+            <a:r>
+              <a:rPr sz="1500" b="0" i="0" baseline="-25000">
+                <a:solidFill>
+                  <a:srgbClr val="666677"/>
+                </a:solidFill>
+                <a:latin typeface="Helvetica"/>
+              </a:rPr>
+              <a:t>S</a:t>
+            </a:r>
+            <a:r>
+              <a:rPr sz="1500" b="0" i="0">
+                <a:solidFill>
+                  <a:srgbClr val="666677"/>
+                </a:solidFill>
+                <a:latin typeface="Helvetica"/>
+              </a:rPr>
+              <a:t> (small)</a:t>
             </a:r>
           </a:p>
         </p:txBody>
@@ -11278,7 +11743,7 @@
                 </a:solidFill>
                 <a:latin typeface="Helvetica"/>
               </a:rPr>
-              <a:t>•  Has explicit small / medium / large size buckets (APₛ / APₘ / APₗ).</a:t>
+              <a:t>•  Has explicit small / medium / large size buckets (S / M / L).</a:t>
             </a:r>
           </a:p>
         </p:txBody>

</xml_diff>

<commit_message>
feat(presentation): add 4th spotlight on the 800-resolution APₛ=37.01 number
Same pattern as the previous three: a duplicate slide with a green
circle around the headline number (37.01) that appears on the next
click. Total: 28 slides (24 content + 4 spotlights).
</commit_message>
<xml_diff>
--- a/presentation/feedback_rtdetr_presentation.pptx
+++ b/presentation/feedback_rtdetr_presentation.pptx
@@ -32,6 +32,7 @@
     <p:sldId id="280" r:id="rId31"/>
     <p:sldId id="281" r:id="rId32"/>
     <p:sldId id="282" r:id="rId33"/>
+    <p:sldId id="283" r:id="rId34"/>
   </p:sldIdLst>
   <p:sldSz cx="12191695" cy="6858000" type="screen4x3"/>
   <p:notesSz cx="6858000" cy="9144000"/>
@@ -3517,7 +3518,7 @@
                 </a:solidFill>
                 <a:latin typeface="Helvetica"/>
               </a:rPr>
-              <a:t>9 / 27</a:t>
+              <a:t>9 / 28</a:t>
             </a:r>
           </a:p>
         </p:txBody>
@@ -3707,7 +3708,7 @@
                 </a:solidFill>
                 <a:latin typeface="Helvetica"/>
               </a:rPr>
-              <a:t>10 / 27</a:t>
+              <a:t>10 / 28</a:t>
             </a:r>
           </a:p>
         </p:txBody>
@@ -4067,7 +4068,7 @@
                 </a:solidFill>
                 <a:latin typeface="Helvetica"/>
               </a:rPr>
-              <a:t>11 / 27</a:t>
+              <a:t>11 / 28</a:t>
             </a:r>
           </a:p>
         </p:txBody>
@@ -4471,7 +4472,7 @@
                 </a:solidFill>
                 <a:latin typeface="Helvetica"/>
               </a:rPr>
-              <a:t>12 / 27</a:t>
+              <a:t>12 / 28</a:t>
             </a:r>
           </a:p>
         </p:txBody>
@@ -4696,7 +4697,7 @@
                 </a:solidFill>
                 <a:latin typeface="Helvetica"/>
               </a:rPr>
-              <a:t>13 / 27</a:t>
+              <a:t>13 / 28</a:t>
             </a:r>
           </a:p>
         </p:txBody>
@@ -4932,7 +4933,7 @@
                 </a:solidFill>
                 <a:latin typeface="Helvetica"/>
               </a:rPr>
-              <a:t>14 / 27</a:t>
+              <a:t>14 / 28</a:t>
             </a:r>
           </a:p>
         </p:txBody>
@@ -5636,7 +5637,7 @@
                 </a:solidFill>
                 <a:latin typeface="Helvetica"/>
               </a:rPr>
-              <a:t>15 / 27</a:t>
+              <a:t>15 / 28</a:t>
             </a:r>
           </a:p>
         </p:txBody>
@@ -5872,7 +5873,7 @@
                 </a:solidFill>
                 <a:latin typeface="Helvetica"/>
               </a:rPr>
-              <a:t>16 / 27</a:t>
+              <a:t>16 / 28</a:t>
             </a:r>
           </a:p>
         </p:txBody>
@@ -6097,7 +6098,7 @@
                 </a:solidFill>
                 <a:latin typeface="Helvetica"/>
               </a:rPr>
-              <a:t>17 / 27</a:t>
+              <a:t>17 / 28</a:t>
             </a:r>
           </a:p>
         </p:txBody>
@@ -6436,7 +6437,7 @@
                 </a:solidFill>
                 <a:latin typeface="Helvetica"/>
               </a:rPr>
-              <a:t>18 / 27</a:t>
+              <a:t>18 / 28</a:t>
             </a:r>
           </a:p>
         </p:txBody>
@@ -6672,7 +6673,7 @@
                 </a:solidFill>
                 <a:latin typeface="Helvetica"/>
               </a:rPr>
-              <a:t>1 / 27</a:t>
+              <a:t>1 / 28</a:t>
             </a:r>
           </a:p>
         </p:txBody>
@@ -7167,7 +7168,7 @@
                 </a:solidFill>
                 <a:latin typeface="Helvetica"/>
               </a:rPr>
-              <a:t>19 / 27</a:t>
+              <a:t>19 / 28</a:t>
             </a:r>
           </a:p>
         </p:txBody>
@@ -7683,7 +7684,7 @@
                 </a:solidFill>
                 <a:latin typeface="Helvetica"/>
               </a:rPr>
-              <a:t>20 / 27</a:t>
+              <a:t>20 / 28</a:t>
             </a:r>
           </a:p>
         </p:txBody>
@@ -8243,7 +8244,7 @@
                 </a:solidFill>
                 <a:latin typeface="Helvetica"/>
               </a:rPr>
-              <a:t>21 / 27</a:t>
+              <a:t>21 / 28</a:t>
             </a:r>
           </a:p>
         </p:txBody>
@@ -8662,7 +8663,7 @@
                 </a:solidFill>
                 <a:latin typeface="Helvetica"/>
               </a:rPr>
-              <a:t>22 / 27</a:t>
+              <a:t>22 / 28</a:t>
             </a:r>
           </a:p>
         </p:txBody>
@@ -8715,7 +8716,7 @@
                 </a:solidFill>
                 <a:latin typeface="Helvetica"/>
               </a:rPr>
-              <a:t>Strengths and limitations</a:t>
+              <a:t>Higher resolution → bigger gain</a:t>
             </a:r>
           </a:p>
         </p:txBody>
@@ -8765,22 +8766,273 @@
       </p:sp>
       <p:sp>
         <p:nvSpPr>
-          <p:cNvPr id="4" name="Rounded Rectangle 3"/>
+          <p:cNvPr id="4" name="TextBox 3"/>
+          <p:cNvSpPr txBox="1"/>
+          <p:nvPr/>
+        </p:nvSpPr>
+        <p:spPr>
+          <a:xfrm>
+            <a:off x="640080" y="2194560"/>
+            <a:ext cx="5303520" cy="457200"/>
+          </a:xfrm>
+          <a:prstGeom prst="rect">
+            <a:avLst/>
+          </a:prstGeom>
+          <a:noFill/>
+        </p:spPr>
+        <p:txBody>
+          <a:bodyPr wrap="square" lIns="0" rIns="0" tIns="0" bIns="0" anchor="t">
+            <a:spAutoFit/>
+          </a:bodyPr>
+          <a:lstStyle/>
+          <a:p>
+            <a:pPr algn="ctr"/>
+            <a:r>
+              <a:rPr sz="2200" b="0" i="0">
+                <a:solidFill>
+                  <a:srgbClr val="666677"/>
+                </a:solidFill>
+                <a:latin typeface="Helvetica"/>
+              </a:rPr>
+              <a:t>640 × 640</a:t>
+            </a:r>
+          </a:p>
+        </p:txBody>
+      </p:sp>
+      <p:sp>
+        <p:nvSpPr>
+          <p:cNvPr id="5" name="TextBox 4"/>
+          <p:cNvSpPr txBox="1"/>
+          <p:nvPr/>
+        </p:nvSpPr>
+        <p:spPr>
+          <a:xfrm>
+            <a:off x="640080" y="2743200"/>
+            <a:ext cx="5303520" cy="1828800"/>
+          </a:xfrm>
+          <a:prstGeom prst="rect">
+            <a:avLst/>
+          </a:prstGeom>
+          <a:noFill/>
+        </p:spPr>
+        <p:txBody>
+          <a:bodyPr wrap="square" lIns="0" rIns="0" tIns="0" bIns="0" anchor="t">
+            <a:spAutoFit/>
+          </a:bodyPr>
+          <a:lstStyle/>
+          <a:p>
+            <a:pPr algn="ctr"/>
+            <a:r>
+              <a:rPr sz="8800" b="1" i="0">
+                <a:solidFill>
+                  <a:srgbClr val="1A1A2E"/>
+                </a:solidFill>
+                <a:latin typeface="Helvetica"/>
+              </a:rPr>
+              <a:t>34.25</a:t>
+            </a:r>
+          </a:p>
+        </p:txBody>
+      </p:sp>
+      <p:sp>
+        <p:nvSpPr>
+          <p:cNvPr id="6" name="Right Arrow 5"/>
           <p:cNvSpPr/>
           <p:nvPr/>
         </p:nvSpPr>
         <p:spPr>
           <a:xfrm>
-            <a:off x="640080" y="1645920"/>
-            <a:ext cx="5394960" cy="4297680"/>
-          </a:xfrm>
-          <a:prstGeom prst="roundRect">
+            <a:off x="5303520" y="3291840"/>
+            <a:ext cx="1554480" cy="548640"/>
+          </a:xfrm>
+          <a:prstGeom prst="rightArrow">
             <a:avLst/>
           </a:prstGeom>
           <a:solidFill>
-            <a:srgbClr val="E8F7E8"/>
+            <a:srgbClr val="1F6FEB"/>
           </a:solidFill>
-          <a:ln w="19050">
+          <a:ln>
+            <a:noFill/>
+          </a:ln>
+        </p:spPr>
+        <p:style>
+          <a:lnRef idx="1">
+            <a:schemeClr val="accent1"/>
+          </a:lnRef>
+          <a:fillRef idx="3">
+            <a:schemeClr val="accent1"/>
+          </a:fillRef>
+          <a:effectRef idx="2">
+            <a:schemeClr val="accent1"/>
+          </a:effectRef>
+          <a:fontRef idx="minor">
+            <a:schemeClr val="lt1"/>
+          </a:fontRef>
+        </p:style>
+        <p:txBody>
+          <a:bodyPr rtlCol="0" anchor="ctr"/>
+          <a:lstStyle/>
+          <a:p>
+            <a:pPr algn="ctr"/>
+          </a:p>
+        </p:txBody>
+      </p:sp>
+      <p:sp>
+        <p:nvSpPr>
+          <p:cNvPr id="7" name="TextBox 6"/>
+          <p:cNvSpPr txBox="1"/>
+          <p:nvPr/>
+        </p:nvSpPr>
+        <p:spPr>
+          <a:xfrm>
+            <a:off x="6217920" y="2194560"/>
+            <a:ext cx="5303520" cy="457200"/>
+          </a:xfrm>
+          <a:prstGeom prst="rect">
+            <a:avLst/>
+          </a:prstGeom>
+          <a:noFill/>
+        </p:spPr>
+        <p:txBody>
+          <a:bodyPr wrap="square" lIns="0" rIns="0" tIns="0" bIns="0" anchor="t">
+            <a:spAutoFit/>
+          </a:bodyPr>
+          <a:lstStyle/>
+          <a:p>
+            <a:pPr algn="ctr"/>
+            <a:r>
+              <a:rPr sz="2200" b="1" i="0">
+                <a:solidFill>
+                  <a:srgbClr val="1F6FEB"/>
+                </a:solidFill>
+                <a:latin typeface="Helvetica"/>
+              </a:rPr>
+              <a:t>800 × 800</a:t>
+            </a:r>
+          </a:p>
+        </p:txBody>
+      </p:sp>
+      <p:sp>
+        <p:nvSpPr>
+          <p:cNvPr id="8" name="TextBox 7"/>
+          <p:cNvSpPr txBox="1"/>
+          <p:nvPr/>
+        </p:nvSpPr>
+        <p:spPr>
+          <a:xfrm>
+            <a:off x="6217920" y="2743200"/>
+            <a:ext cx="5303520" cy="1828800"/>
+          </a:xfrm>
+          <a:prstGeom prst="rect">
+            <a:avLst/>
+          </a:prstGeom>
+          <a:noFill/>
+        </p:spPr>
+        <p:txBody>
+          <a:bodyPr wrap="square" lIns="0" rIns="0" tIns="0" bIns="0" anchor="t">
+            <a:spAutoFit/>
+          </a:bodyPr>
+          <a:lstStyle/>
+          <a:p>
+            <a:pPr algn="ctr"/>
+            <a:r>
+              <a:rPr sz="8800" b="1" i="0">
+                <a:solidFill>
+                  <a:srgbClr val="2CA02C"/>
+                </a:solidFill>
+                <a:latin typeface="Helvetica"/>
+              </a:rPr>
+              <a:t>37.01</a:t>
+            </a:r>
+          </a:p>
+        </p:txBody>
+      </p:sp>
+      <p:sp>
+        <p:nvSpPr>
+          <p:cNvPr id="9" name="TextBox 8"/>
+          <p:cNvSpPr txBox="1"/>
+          <p:nvPr/>
+        </p:nvSpPr>
+        <p:spPr>
+          <a:xfrm>
+            <a:off x="640080" y="5120640"/>
+            <a:ext cx="10972800" cy="457200"/>
+          </a:xfrm>
+          <a:prstGeom prst="rect">
+            <a:avLst/>
+          </a:prstGeom>
+          <a:noFill/>
+        </p:spPr>
+        <p:txBody>
+          <a:bodyPr wrap="square" lIns="0" rIns="0" tIns="0" bIns="0" anchor="t">
+            <a:spAutoFit/>
+          </a:bodyPr>
+          <a:lstStyle/>
+          <a:p>
+            <a:pPr algn="ctr"/>
+            <a:r>
+              <a:rPr sz="2200" b="0" i="1">
+                <a:solidFill>
+                  <a:srgbClr val="1A1A2E"/>
+                </a:solidFill>
+                <a:latin typeface="Helvetica"/>
+              </a:rPr>
+              <a:t>+2.76 from more pixels.</a:t>
+            </a:r>
+          </a:p>
+        </p:txBody>
+      </p:sp>
+      <p:sp>
+        <p:nvSpPr>
+          <p:cNvPr id="10" name="TextBox 9"/>
+          <p:cNvSpPr txBox="1"/>
+          <p:nvPr/>
+        </p:nvSpPr>
+        <p:spPr>
+          <a:xfrm>
+            <a:off x="640080" y="5669280"/>
+            <a:ext cx="10972800" cy="457200"/>
+          </a:xfrm>
+          <a:prstGeom prst="rect">
+            <a:avLst/>
+          </a:prstGeom>
+          <a:noFill/>
+        </p:spPr>
+        <p:txBody>
+          <a:bodyPr wrap="square" lIns="0" rIns="0" tIns="0" bIns="0" anchor="t">
+            <a:spAutoFit/>
+          </a:bodyPr>
+          <a:lstStyle/>
+          <a:p>
+            <a:pPr algn="ctr"/>
+            <a:r>
+              <a:rPr sz="1600" b="0" i="0">
+                <a:solidFill>
+                  <a:srgbClr val="666677"/>
+                </a:solidFill>
+                <a:latin typeface="Helvetica"/>
+              </a:rPr>
+              <a:t>Feedback helps. Spatial sampling helps too.</a:t>
+            </a:r>
+          </a:p>
+        </p:txBody>
+      </p:sp>
+      <p:sp>
+        <p:nvSpPr>
+          <p:cNvPr id="11" name="Oval 10"/>
+          <p:cNvSpPr/>
+          <p:nvPr/>
+        </p:nvSpPr>
+        <p:spPr>
+          <a:xfrm>
+            <a:off x="6675120" y="2697480"/>
+            <a:ext cx="4389120" cy="1920240"/>
+          </a:xfrm>
+          <a:prstGeom prst="ellipse">
+            <a:avLst/>
+          </a:prstGeom>
+          <a:noFill/>
+          <a:ln w="63500">
             <a:solidFill>
               <a:srgbClr val="2CA02C"/>
             </a:solidFill>
@@ -8811,438 +9063,7 @@
       </p:sp>
       <p:sp>
         <p:nvSpPr>
-          <p:cNvPr id="5" name="TextBox 4"/>
-          <p:cNvSpPr txBox="1"/>
-          <p:nvPr/>
-        </p:nvSpPr>
-        <p:spPr>
-          <a:xfrm>
-            <a:off x="822960" y="1828800"/>
-            <a:ext cx="5029200" cy="548640"/>
-          </a:xfrm>
-          <a:prstGeom prst="rect">
-            <a:avLst/>
-          </a:prstGeom>
-          <a:noFill/>
-        </p:spPr>
-        <p:txBody>
-          <a:bodyPr wrap="square" lIns="0" rIns="0" tIns="0" bIns="0" anchor="t">
-            <a:spAutoFit/>
-          </a:bodyPr>
-          <a:lstStyle/>
-          <a:p>
-            <a:pPr algn="l"/>
-            <a:r>
-              <a:rPr sz="2200" b="1" i="0">
-                <a:solidFill>
-                  <a:srgbClr val="2CA02C"/>
-                </a:solidFill>
-                <a:latin typeface="Helvetica"/>
-              </a:rPr>
-              <a:t>+  Strengths</a:t>
-            </a:r>
-          </a:p>
-        </p:txBody>
-      </p:sp>
-      <p:sp>
-        <p:nvSpPr>
-          <p:cNvPr id="6" name="TextBox 5"/>
-          <p:cNvSpPr txBox="1"/>
-          <p:nvPr/>
-        </p:nvSpPr>
-        <p:spPr>
-          <a:xfrm>
-            <a:off x="868680" y="2468880"/>
-            <a:ext cx="5029200" cy="731520"/>
-          </a:xfrm>
-          <a:prstGeom prst="rect">
-            <a:avLst/>
-          </a:prstGeom>
-          <a:noFill/>
-        </p:spPr>
-        <p:txBody>
-          <a:bodyPr wrap="square" lIns="0" rIns="0" tIns="0" bIns="0" anchor="t">
-            <a:spAutoFit/>
-          </a:bodyPr>
-          <a:lstStyle/>
-          <a:p>
-            <a:pPr algn="l"/>
-            <a:r>
-              <a:rPr sz="1400" b="0" i="0">
-                <a:solidFill>
-                  <a:srgbClr val="1A1A2E"/>
-                </a:solidFill>
-                <a:latin typeface="Helvetica"/>
-              </a:rPr>
-              <a:t>•  Causal contribution: +0.99 on small-object AP, same checkpoint.</a:t>
-            </a:r>
-          </a:p>
-        </p:txBody>
-      </p:sp>
-      <p:sp>
-        <p:nvSpPr>
-          <p:cNvPr id="7" name="TextBox 6"/>
-          <p:cNvSpPr txBox="1"/>
-          <p:nvPr/>
-        </p:nvSpPr>
-        <p:spPr>
-          <a:xfrm>
-            <a:off x="868680" y="3246120"/>
-            <a:ext cx="5029200" cy="731520"/>
-          </a:xfrm>
-          <a:prstGeom prst="rect">
-            <a:avLst/>
-          </a:prstGeom>
-          <a:noFill/>
-        </p:spPr>
-        <p:txBody>
-          <a:bodyPr wrap="square" lIns="0" rIns="0" tIns="0" bIns="0" anchor="t">
-            <a:spAutoFit/>
-          </a:bodyPr>
-          <a:lstStyle/>
-          <a:p>
-            <a:pPr algn="l"/>
-            <a:r>
-              <a:rPr sz="1400" b="0" i="0">
-                <a:solidFill>
-                  <a:srgbClr val="1A1A2E"/>
-                </a:solidFill>
-                <a:latin typeface="Helvetica"/>
-              </a:rPr>
-              <a:t>•  Zero new parameters relative to v1.</a:t>
-            </a:r>
-          </a:p>
-        </p:txBody>
-      </p:sp>
-      <p:sp>
-        <p:nvSpPr>
-          <p:cNvPr id="8" name="TextBox 7"/>
-          <p:cNvSpPr txBox="1"/>
-          <p:nvPr/>
-        </p:nvSpPr>
-        <p:spPr>
-          <a:xfrm>
-            <a:off x="868680" y="4023360"/>
-            <a:ext cx="5029200" cy="731520"/>
-          </a:xfrm>
-          <a:prstGeom prst="rect">
-            <a:avLst/>
-          </a:prstGeom>
-          <a:noFill/>
-        </p:spPr>
-        <p:txBody>
-          <a:bodyPr wrap="square" lIns="0" rIns="0" tIns="0" bIns="0" anchor="t">
-            <a:spAutoFit/>
-          </a:bodyPr>
-          <a:lstStyle/>
-          <a:p>
-            <a:pPr algn="l"/>
-            <a:r>
-              <a:rPr sz="1400" b="0" i="0">
-                <a:solidFill>
-                  <a:srgbClr val="1A1A2E"/>
-                </a:solidFill>
-                <a:latin typeface="Helvetica"/>
-              </a:rPr>
-              <a:t>•  Consistent improvement on every metric (AP, S, M, L).</a:t>
-            </a:r>
-          </a:p>
-        </p:txBody>
-      </p:sp>
-      <p:sp>
-        <p:nvSpPr>
-          <p:cNvPr id="9" name="TextBox 8"/>
-          <p:cNvSpPr txBox="1"/>
-          <p:nvPr/>
-        </p:nvSpPr>
-        <p:spPr>
-          <a:xfrm>
-            <a:off x="868680" y="4800600"/>
-            <a:ext cx="5029200" cy="731520"/>
-          </a:xfrm>
-          <a:prstGeom prst="rect">
-            <a:avLst/>
-          </a:prstGeom>
-          <a:noFill/>
-        </p:spPr>
-        <p:txBody>
-          <a:bodyPr wrap="square" lIns="0" rIns="0" tIns="0" bIns="0" anchor="t">
-            <a:spAutoFit/>
-          </a:bodyPr>
-          <a:lstStyle/>
-          <a:p>
-            <a:pPr algn="l"/>
-            <a:r>
-              <a:rPr sz="1400" b="0" i="0">
-                <a:solidFill>
-                  <a:srgbClr val="1A1A2E"/>
-                </a:solidFill>
-                <a:latin typeface="Helvetica"/>
-              </a:rPr>
-              <a:t>•  Robust at higher resolution (37.01 small-object AP at 800×800).</a:t>
-            </a:r>
-          </a:p>
-        </p:txBody>
-      </p:sp>
-      <p:sp>
-        <p:nvSpPr>
-          <p:cNvPr id="10" name="Rounded Rectangle 9"/>
-          <p:cNvSpPr/>
-          <p:nvPr/>
-        </p:nvSpPr>
-        <p:spPr>
-          <a:xfrm>
-            <a:off x="6217920" y="1645920"/>
-            <a:ext cx="5394960" cy="4297680"/>
-          </a:xfrm>
-          <a:prstGeom prst="roundRect">
-            <a:avLst/>
-          </a:prstGeom>
-          <a:solidFill>
-            <a:srgbClr val="FDECEC"/>
-          </a:solidFill>
-          <a:ln w="19050">
-            <a:solidFill>
-              <a:srgbClr val="D62C2E"/>
-            </a:solidFill>
-          </a:ln>
-          <a:effectLst/>
-        </p:spPr>
-        <p:style>
-          <a:lnRef idx="1">
-            <a:schemeClr val="accent1"/>
-          </a:lnRef>
-          <a:fillRef idx="3">
-            <a:schemeClr val="accent1"/>
-          </a:fillRef>
-          <a:effectRef idx="2">
-            <a:schemeClr val="accent1"/>
-          </a:effectRef>
-          <a:fontRef idx="minor">
-            <a:schemeClr val="lt1"/>
-          </a:fontRef>
-        </p:style>
-        <p:txBody>
-          <a:bodyPr rtlCol="0" anchor="ctr"/>
-          <a:lstStyle/>
-          <a:p>
-            <a:pPr algn="ctr"/>
-          </a:p>
-        </p:txBody>
-      </p:sp>
-      <p:sp>
-        <p:nvSpPr>
-          <p:cNvPr id="11" name="TextBox 10"/>
-          <p:cNvSpPr txBox="1"/>
-          <p:nvPr/>
-        </p:nvSpPr>
-        <p:spPr>
-          <a:xfrm>
-            <a:off x="6400800" y="1828800"/>
-            <a:ext cx="5029200" cy="548640"/>
-          </a:xfrm>
-          <a:prstGeom prst="rect">
-            <a:avLst/>
-          </a:prstGeom>
-          <a:noFill/>
-        </p:spPr>
-        <p:txBody>
-          <a:bodyPr wrap="square" lIns="0" rIns="0" tIns="0" bIns="0" anchor="t">
-            <a:spAutoFit/>
-          </a:bodyPr>
-          <a:lstStyle/>
-          <a:p>
-            <a:pPr algn="l"/>
-            <a:r>
-              <a:rPr sz="2200" b="1" i="0">
-                <a:solidFill>
-                  <a:srgbClr val="D62C2E"/>
-                </a:solidFill>
-                <a:latin typeface="Helvetica"/>
-              </a:rPr>
-              <a:t>−  Limitations</a:t>
-            </a:r>
-          </a:p>
-        </p:txBody>
-      </p:sp>
-      <p:sp>
-        <p:nvSpPr>
           <p:cNvPr id="12" name="TextBox 11"/>
-          <p:cNvSpPr txBox="1"/>
-          <p:nvPr/>
-        </p:nvSpPr>
-        <p:spPr>
-          <a:xfrm>
-            <a:off x="6446520" y="2468880"/>
-            <a:ext cx="5029200" cy="731520"/>
-          </a:xfrm>
-          <a:prstGeom prst="rect">
-            <a:avLst/>
-          </a:prstGeom>
-          <a:noFill/>
-        </p:spPr>
-        <p:txBody>
-          <a:bodyPr wrap="square" lIns="0" rIns="0" tIns="0" bIns="0" anchor="t">
-            <a:spAutoFit/>
-          </a:bodyPr>
-          <a:lstStyle/>
-          <a:p>
-            <a:pPr algn="l"/>
-            <a:r>
-              <a:rPr sz="1400" b="0" i="0">
-                <a:solidFill>
-                  <a:srgbClr val="1A1A2E"/>
-                </a:solidFill>
-                <a:latin typeface="Helvetica"/>
-              </a:rPr>
-              <a:t>•  Single seed — multi-seed variance unmeasured.</a:t>
-            </a:r>
-          </a:p>
-        </p:txBody>
-      </p:sp>
-      <p:sp>
-        <p:nvSpPr>
-          <p:cNvPr id="13" name="TextBox 12"/>
-          <p:cNvSpPr txBox="1"/>
-          <p:nvPr/>
-        </p:nvSpPr>
-        <p:spPr>
-          <a:xfrm>
-            <a:off x="6446520" y="3246120"/>
-            <a:ext cx="5029200" cy="731520"/>
-          </a:xfrm>
-          <a:prstGeom prst="rect">
-            <a:avLst/>
-          </a:prstGeom>
-          <a:noFill/>
-        </p:spPr>
-        <p:txBody>
-          <a:bodyPr wrap="square" lIns="0" rIns="0" tIns="0" bIns="0" anchor="t">
-            <a:spAutoFit/>
-          </a:bodyPr>
-          <a:lstStyle/>
-          <a:p>
-            <a:pPr algn="l"/>
-            <a:r>
-              <a:rPr sz="1400" b="0" i="0">
-                <a:solidFill>
-                  <a:srgbClr val="1A1A2E"/>
-                </a:solidFill>
-                <a:latin typeface="Helvetica"/>
-              </a:rPr>
-              <a:t>•  13-epoch finetune (vs 72-epoch from scratch).</a:t>
-            </a:r>
-          </a:p>
-        </p:txBody>
-      </p:sp>
-      <p:sp>
-        <p:nvSpPr>
-          <p:cNvPr id="14" name="TextBox 13"/>
-          <p:cNvSpPr txBox="1"/>
-          <p:nvPr/>
-        </p:nvSpPr>
-        <p:spPr>
-          <a:xfrm>
-            <a:off x="6446520" y="4023360"/>
-            <a:ext cx="5029200" cy="731520"/>
-          </a:xfrm>
-          <a:prstGeom prst="rect">
-            <a:avLst/>
-          </a:prstGeom>
-          <a:noFill/>
-        </p:spPr>
-        <p:txBody>
-          <a:bodyPr wrap="square" lIns="0" rIns="0" tIns="0" bIns="0" anchor="t">
-            <a:spAutoFit/>
-          </a:bodyPr>
-          <a:lstStyle/>
-          <a:p>
-            <a:pPr algn="l"/>
-            <a:r>
-              <a:rPr sz="1400" b="0" i="0">
-                <a:solidFill>
-                  <a:srgbClr val="1A1A2E"/>
-                </a:solidFill>
-                <a:latin typeface="Helvetica"/>
-              </a:rPr>
-              <a:t>•  Floor and mask not isolated (a 2×2 ablation is missing).</a:t>
-            </a:r>
-          </a:p>
-        </p:txBody>
-      </p:sp>
-      <p:sp>
-        <p:nvSpPr>
-          <p:cNvPr id="15" name="TextBox 14"/>
-          <p:cNvSpPr txBox="1"/>
-          <p:nvPr/>
-        </p:nvSpPr>
-        <p:spPr>
-          <a:xfrm>
-            <a:off x="6446520" y="4800600"/>
-            <a:ext cx="5029200" cy="731520"/>
-          </a:xfrm>
-          <a:prstGeom prst="rect">
-            <a:avLst/>
-          </a:prstGeom>
-          <a:noFill/>
-        </p:spPr>
-        <p:txBody>
-          <a:bodyPr wrap="square" lIns="0" rIns="0" tIns="0" bIns="0" anchor="t">
-            <a:spAutoFit/>
-          </a:bodyPr>
-          <a:lstStyle/>
-          <a:p>
-            <a:pPr algn="l"/>
-            <a:r>
-              <a:rPr sz="1400" b="0" i="0">
-                <a:solidFill>
-                  <a:srgbClr val="1A1A2E"/>
-                </a:solidFill>
-                <a:latin typeface="Helvetica"/>
-              </a:rPr>
-              <a:t>•  ≈2× slower than baseline (53 → 26 FPS) — cost is the P2 level.</a:t>
-            </a:r>
-          </a:p>
-        </p:txBody>
-      </p:sp>
-      <p:sp>
-        <p:nvSpPr>
-          <p:cNvPr id="16" name="TextBox 15"/>
-          <p:cNvSpPr txBox="1"/>
-          <p:nvPr/>
-        </p:nvSpPr>
-        <p:spPr>
-          <a:xfrm>
-            <a:off x="640080" y="6080760"/>
-            <a:ext cx="10972800" cy="365760"/>
-          </a:xfrm>
-          <a:prstGeom prst="rect">
-            <a:avLst/>
-          </a:prstGeom>
-          <a:noFill/>
-        </p:spPr>
-        <p:txBody>
-          <a:bodyPr wrap="square" lIns="0" rIns="0" tIns="0" bIns="0" anchor="t">
-            <a:spAutoFit/>
-          </a:bodyPr>
-          <a:lstStyle/>
-          <a:p>
-            <a:pPr algn="ctr"/>
-            <a:r>
-              <a:rPr sz="1200" b="0" i="1">
-                <a:solidFill>
-                  <a:srgbClr val="666677"/>
-                </a:solidFill>
-                <a:latin typeface="Helvetica"/>
-              </a:rPr>
-              <a:t>Strong on accuracy; pays in inference speed. The next slide proposes a way to recover speed.</a:t>
-            </a:r>
-          </a:p>
-        </p:txBody>
-      </p:sp>
-      <p:sp>
-        <p:nvSpPr>
-          <p:cNvPr id="17" name="TextBox 16"/>
           <p:cNvSpPr txBox="1"/>
           <p:nvPr/>
         </p:nvSpPr>
@@ -9277,7 +9098,7 @@
       </p:sp>
       <p:sp>
         <p:nvSpPr>
-          <p:cNvPr id="18" name="TextBox 17"/>
+          <p:cNvPr id="13" name="TextBox 12"/>
           <p:cNvSpPr txBox="1"/>
           <p:nvPr/>
         </p:nvSpPr>
@@ -9305,7 +9126,7 @@
                 </a:solidFill>
                 <a:latin typeface="Helvetica"/>
               </a:rPr>
-              <a:t>23 / 27</a:t>
+              <a:t>23 / 28</a:t>
             </a:r>
           </a:p>
         </p:txBody>
@@ -9358,7 +9179,7 @@
                 </a:solidFill>
                 <a:latin typeface="Helvetica"/>
               </a:rPr>
-              <a:t>Future work: recovering inference speed</a:t>
+              <a:t>Strengths and limitations</a:t>
             </a:r>
           </a:p>
         </p:txBody>
@@ -9408,59 +9229,24 @@
       </p:sp>
       <p:sp>
         <p:nvSpPr>
-          <p:cNvPr id="4" name="TextBox 3"/>
-          <p:cNvSpPr txBox="1"/>
-          <p:nvPr/>
-        </p:nvSpPr>
-        <p:spPr>
-          <a:xfrm>
-            <a:off x="640080" y="1417320"/>
-            <a:ext cx="10972800" cy="457200"/>
-          </a:xfrm>
-          <a:prstGeom prst="rect">
-            <a:avLst/>
-          </a:prstGeom>
-          <a:noFill/>
-        </p:spPr>
-        <p:txBody>
-          <a:bodyPr wrap="square" lIns="0" rIns="0" tIns="0" bIns="0" anchor="t">
-            <a:spAutoFit/>
-          </a:bodyPr>
-          <a:lstStyle/>
-          <a:p>
-            <a:pPr algn="ctr"/>
-            <a:r>
-              <a:rPr sz="1800" b="0" i="1">
-                <a:solidFill>
-                  <a:srgbClr val="1A1A2E"/>
-                </a:solidFill>
-                <a:latin typeface="Helvetica"/>
-              </a:rPr>
-              <a:t>The 2× slowdown comes from the P2 level, not the feedback module.</a:t>
-            </a:r>
-          </a:p>
-        </p:txBody>
-      </p:sp>
-      <p:sp>
-        <p:nvSpPr>
-          <p:cNvPr id="5" name="Rounded Rectangle 4"/>
+          <p:cNvPr id="4" name="Rounded Rectangle 3"/>
           <p:cNvSpPr/>
           <p:nvPr/>
         </p:nvSpPr>
         <p:spPr>
           <a:xfrm>
-            <a:off x="640080" y="2194560"/>
-            <a:ext cx="3657600" cy="3657600"/>
+            <a:off x="640080" y="1645920"/>
+            <a:ext cx="5394960" cy="4297680"/>
           </a:xfrm>
           <a:prstGeom prst="roundRect">
             <a:avLst/>
           </a:prstGeom>
           <a:solidFill>
-            <a:srgbClr val="F0F6FF"/>
+            <a:srgbClr val="E8F7E8"/>
           </a:solidFill>
-          <a:ln w="15240">
+          <a:ln w="19050">
             <a:solidFill>
-              <a:srgbClr val="1F6FEB"/>
+              <a:srgbClr val="2CA02C"/>
             </a:solidFill>
           </a:ln>
           <a:effectLst/>
@@ -9489,24 +9275,202 @@
       </p:sp>
       <p:sp>
         <p:nvSpPr>
-          <p:cNvPr id="6" name="Oval 5"/>
+          <p:cNvPr id="5" name="TextBox 4"/>
+          <p:cNvSpPr txBox="1"/>
+          <p:nvPr/>
+        </p:nvSpPr>
+        <p:spPr>
+          <a:xfrm>
+            <a:off x="822960" y="1828800"/>
+            <a:ext cx="5029200" cy="548640"/>
+          </a:xfrm>
+          <a:prstGeom prst="rect">
+            <a:avLst/>
+          </a:prstGeom>
+          <a:noFill/>
+        </p:spPr>
+        <p:txBody>
+          <a:bodyPr wrap="square" lIns="0" rIns="0" tIns="0" bIns="0" anchor="t">
+            <a:spAutoFit/>
+          </a:bodyPr>
+          <a:lstStyle/>
+          <a:p>
+            <a:pPr algn="l"/>
+            <a:r>
+              <a:rPr sz="2200" b="1" i="0">
+                <a:solidFill>
+                  <a:srgbClr val="2CA02C"/>
+                </a:solidFill>
+                <a:latin typeface="Helvetica"/>
+              </a:rPr>
+              <a:t>+  Strengths</a:t>
+            </a:r>
+          </a:p>
+        </p:txBody>
+      </p:sp>
+      <p:sp>
+        <p:nvSpPr>
+          <p:cNvPr id="6" name="TextBox 5"/>
+          <p:cNvSpPr txBox="1"/>
+          <p:nvPr/>
+        </p:nvSpPr>
+        <p:spPr>
+          <a:xfrm>
+            <a:off x="868680" y="2468880"/>
+            <a:ext cx="5029200" cy="731520"/>
+          </a:xfrm>
+          <a:prstGeom prst="rect">
+            <a:avLst/>
+          </a:prstGeom>
+          <a:noFill/>
+        </p:spPr>
+        <p:txBody>
+          <a:bodyPr wrap="square" lIns="0" rIns="0" tIns="0" bIns="0" anchor="t">
+            <a:spAutoFit/>
+          </a:bodyPr>
+          <a:lstStyle/>
+          <a:p>
+            <a:pPr algn="l"/>
+            <a:r>
+              <a:rPr sz="1400" b="0" i="0">
+                <a:solidFill>
+                  <a:srgbClr val="1A1A2E"/>
+                </a:solidFill>
+                <a:latin typeface="Helvetica"/>
+              </a:rPr>
+              <a:t>•  Causal contribution: +0.99 on small-object AP, same checkpoint.</a:t>
+            </a:r>
+          </a:p>
+        </p:txBody>
+      </p:sp>
+      <p:sp>
+        <p:nvSpPr>
+          <p:cNvPr id="7" name="TextBox 6"/>
+          <p:cNvSpPr txBox="1"/>
+          <p:nvPr/>
+        </p:nvSpPr>
+        <p:spPr>
+          <a:xfrm>
+            <a:off x="868680" y="3246120"/>
+            <a:ext cx="5029200" cy="731520"/>
+          </a:xfrm>
+          <a:prstGeom prst="rect">
+            <a:avLst/>
+          </a:prstGeom>
+          <a:noFill/>
+        </p:spPr>
+        <p:txBody>
+          <a:bodyPr wrap="square" lIns="0" rIns="0" tIns="0" bIns="0" anchor="t">
+            <a:spAutoFit/>
+          </a:bodyPr>
+          <a:lstStyle/>
+          <a:p>
+            <a:pPr algn="l"/>
+            <a:r>
+              <a:rPr sz="1400" b="0" i="0">
+                <a:solidFill>
+                  <a:srgbClr val="1A1A2E"/>
+                </a:solidFill>
+                <a:latin typeface="Helvetica"/>
+              </a:rPr>
+              <a:t>•  Zero new parameters relative to v1.</a:t>
+            </a:r>
+          </a:p>
+        </p:txBody>
+      </p:sp>
+      <p:sp>
+        <p:nvSpPr>
+          <p:cNvPr id="8" name="TextBox 7"/>
+          <p:cNvSpPr txBox="1"/>
+          <p:nvPr/>
+        </p:nvSpPr>
+        <p:spPr>
+          <a:xfrm>
+            <a:off x="868680" y="4023360"/>
+            <a:ext cx="5029200" cy="731520"/>
+          </a:xfrm>
+          <a:prstGeom prst="rect">
+            <a:avLst/>
+          </a:prstGeom>
+          <a:noFill/>
+        </p:spPr>
+        <p:txBody>
+          <a:bodyPr wrap="square" lIns="0" rIns="0" tIns="0" bIns="0" anchor="t">
+            <a:spAutoFit/>
+          </a:bodyPr>
+          <a:lstStyle/>
+          <a:p>
+            <a:pPr algn="l"/>
+            <a:r>
+              <a:rPr sz="1400" b="0" i="0">
+                <a:solidFill>
+                  <a:srgbClr val="1A1A2E"/>
+                </a:solidFill>
+                <a:latin typeface="Helvetica"/>
+              </a:rPr>
+              <a:t>•  Consistent improvement on every metric (AP, S, M, L).</a:t>
+            </a:r>
+          </a:p>
+        </p:txBody>
+      </p:sp>
+      <p:sp>
+        <p:nvSpPr>
+          <p:cNvPr id="9" name="TextBox 8"/>
+          <p:cNvSpPr txBox="1"/>
+          <p:nvPr/>
+        </p:nvSpPr>
+        <p:spPr>
+          <a:xfrm>
+            <a:off x="868680" y="4800600"/>
+            <a:ext cx="5029200" cy="731520"/>
+          </a:xfrm>
+          <a:prstGeom prst="rect">
+            <a:avLst/>
+          </a:prstGeom>
+          <a:noFill/>
+        </p:spPr>
+        <p:txBody>
+          <a:bodyPr wrap="square" lIns="0" rIns="0" tIns="0" bIns="0" anchor="t">
+            <a:spAutoFit/>
+          </a:bodyPr>
+          <a:lstStyle/>
+          <a:p>
+            <a:pPr algn="l"/>
+            <a:r>
+              <a:rPr sz="1400" b="0" i="0">
+                <a:solidFill>
+                  <a:srgbClr val="1A1A2E"/>
+                </a:solidFill>
+                <a:latin typeface="Helvetica"/>
+              </a:rPr>
+              <a:t>•  Robust at higher resolution (37.01 small-object AP at 800×800).</a:t>
+            </a:r>
+          </a:p>
+        </p:txBody>
+      </p:sp>
+      <p:sp>
+        <p:nvSpPr>
+          <p:cNvPr id="10" name="Rounded Rectangle 9"/>
           <p:cNvSpPr/>
           <p:nvPr/>
         </p:nvSpPr>
         <p:spPr>
           <a:xfrm>
-            <a:off x="822960" y="2331720"/>
-            <a:ext cx="457200" cy="457200"/>
-          </a:xfrm>
-          <a:prstGeom prst="ellipse">
+            <a:off x="6217920" y="1645920"/>
+            <a:ext cx="5394960" cy="4297680"/>
+          </a:xfrm>
+          <a:prstGeom prst="roundRect">
             <a:avLst/>
           </a:prstGeom>
           <a:solidFill>
-            <a:srgbClr val="1F6FEB"/>
+            <a:srgbClr val="FDECEC"/>
           </a:solidFill>
-          <a:ln>
-            <a:noFill/>
+          <a:ln w="19050">
+            <a:solidFill>
+              <a:srgbClr val="D62C2E"/>
+            </a:solidFill>
           </a:ln>
+          <a:effectLst/>
         </p:spPr>
         <p:style>
           <a:lnRef idx="1">
@@ -9532,14 +9496,189 @@
       </p:sp>
       <p:sp>
         <p:nvSpPr>
-          <p:cNvPr id="7" name="TextBox 6"/>
-          <p:cNvSpPr txBox="1"/>
-          <p:nvPr/>
-        </p:nvSpPr>
-        <p:spPr>
-          <a:xfrm>
-            <a:off x="822960" y="2359152"/>
-            <a:ext cx="457200" cy="457200"/>
+          <p:cNvPr id="11" name="TextBox 10"/>
+          <p:cNvSpPr txBox="1"/>
+          <p:nvPr/>
+        </p:nvSpPr>
+        <p:spPr>
+          <a:xfrm>
+            <a:off x="6400800" y="1828800"/>
+            <a:ext cx="5029200" cy="548640"/>
+          </a:xfrm>
+          <a:prstGeom prst="rect">
+            <a:avLst/>
+          </a:prstGeom>
+          <a:noFill/>
+        </p:spPr>
+        <p:txBody>
+          <a:bodyPr wrap="square" lIns="0" rIns="0" tIns="0" bIns="0" anchor="t">
+            <a:spAutoFit/>
+          </a:bodyPr>
+          <a:lstStyle/>
+          <a:p>
+            <a:pPr algn="l"/>
+            <a:r>
+              <a:rPr sz="2200" b="1" i="0">
+                <a:solidFill>
+                  <a:srgbClr val="D62C2E"/>
+                </a:solidFill>
+                <a:latin typeface="Helvetica"/>
+              </a:rPr>
+              <a:t>−  Limitations</a:t>
+            </a:r>
+          </a:p>
+        </p:txBody>
+      </p:sp>
+      <p:sp>
+        <p:nvSpPr>
+          <p:cNvPr id="12" name="TextBox 11"/>
+          <p:cNvSpPr txBox="1"/>
+          <p:nvPr/>
+        </p:nvSpPr>
+        <p:spPr>
+          <a:xfrm>
+            <a:off x="6446520" y="2468880"/>
+            <a:ext cx="5029200" cy="731520"/>
+          </a:xfrm>
+          <a:prstGeom prst="rect">
+            <a:avLst/>
+          </a:prstGeom>
+          <a:noFill/>
+        </p:spPr>
+        <p:txBody>
+          <a:bodyPr wrap="square" lIns="0" rIns="0" tIns="0" bIns="0" anchor="t">
+            <a:spAutoFit/>
+          </a:bodyPr>
+          <a:lstStyle/>
+          <a:p>
+            <a:pPr algn="l"/>
+            <a:r>
+              <a:rPr sz="1400" b="0" i="0">
+                <a:solidFill>
+                  <a:srgbClr val="1A1A2E"/>
+                </a:solidFill>
+                <a:latin typeface="Helvetica"/>
+              </a:rPr>
+              <a:t>•  Single seed — multi-seed variance unmeasured.</a:t>
+            </a:r>
+          </a:p>
+        </p:txBody>
+      </p:sp>
+      <p:sp>
+        <p:nvSpPr>
+          <p:cNvPr id="13" name="TextBox 12"/>
+          <p:cNvSpPr txBox="1"/>
+          <p:nvPr/>
+        </p:nvSpPr>
+        <p:spPr>
+          <a:xfrm>
+            <a:off x="6446520" y="3246120"/>
+            <a:ext cx="5029200" cy="731520"/>
+          </a:xfrm>
+          <a:prstGeom prst="rect">
+            <a:avLst/>
+          </a:prstGeom>
+          <a:noFill/>
+        </p:spPr>
+        <p:txBody>
+          <a:bodyPr wrap="square" lIns="0" rIns="0" tIns="0" bIns="0" anchor="t">
+            <a:spAutoFit/>
+          </a:bodyPr>
+          <a:lstStyle/>
+          <a:p>
+            <a:pPr algn="l"/>
+            <a:r>
+              <a:rPr sz="1400" b="0" i="0">
+                <a:solidFill>
+                  <a:srgbClr val="1A1A2E"/>
+                </a:solidFill>
+                <a:latin typeface="Helvetica"/>
+              </a:rPr>
+              <a:t>•  13-epoch finetune (vs 72-epoch from scratch).</a:t>
+            </a:r>
+          </a:p>
+        </p:txBody>
+      </p:sp>
+      <p:sp>
+        <p:nvSpPr>
+          <p:cNvPr id="14" name="TextBox 13"/>
+          <p:cNvSpPr txBox="1"/>
+          <p:nvPr/>
+        </p:nvSpPr>
+        <p:spPr>
+          <a:xfrm>
+            <a:off x="6446520" y="4023360"/>
+            <a:ext cx="5029200" cy="731520"/>
+          </a:xfrm>
+          <a:prstGeom prst="rect">
+            <a:avLst/>
+          </a:prstGeom>
+          <a:noFill/>
+        </p:spPr>
+        <p:txBody>
+          <a:bodyPr wrap="square" lIns="0" rIns="0" tIns="0" bIns="0" anchor="t">
+            <a:spAutoFit/>
+          </a:bodyPr>
+          <a:lstStyle/>
+          <a:p>
+            <a:pPr algn="l"/>
+            <a:r>
+              <a:rPr sz="1400" b="0" i="0">
+                <a:solidFill>
+                  <a:srgbClr val="1A1A2E"/>
+                </a:solidFill>
+                <a:latin typeface="Helvetica"/>
+              </a:rPr>
+              <a:t>•  Floor and mask not isolated (a 2×2 ablation is missing).</a:t>
+            </a:r>
+          </a:p>
+        </p:txBody>
+      </p:sp>
+      <p:sp>
+        <p:nvSpPr>
+          <p:cNvPr id="15" name="TextBox 14"/>
+          <p:cNvSpPr txBox="1"/>
+          <p:nvPr/>
+        </p:nvSpPr>
+        <p:spPr>
+          <a:xfrm>
+            <a:off x="6446520" y="4800600"/>
+            <a:ext cx="5029200" cy="731520"/>
+          </a:xfrm>
+          <a:prstGeom prst="rect">
+            <a:avLst/>
+          </a:prstGeom>
+          <a:noFill/>
+        </p:spPr>
+        <p:txBody>
+          <a:bodyPr wrap="square" lIns="0" rIns="0" tIns="0" bIns="0" anchor="t">
+            <a:spAutoFit/>
+          </a:bodyPr>
+          <a:lstStyle/>
+          <a:p>
+            <a:pPr algn="l"/>
+            <a:r>
+              <a:rPr sz="1400" b="0" i="0">
+                <a:solidFill>
+                  <a:srgbClr val="1A1A2E"/>
+                </a:solidFill>
+                <a:latin typeface="Helvetica"/>
+              </a:rPr>
+              <a:t>•  ≈2× slower than baseline (53 → 26 FPS) — cost is the P2 level.</a:t>
+            </a:r>
+          </a:p>
+        </p:txBody>
+      </p:sp>
+      <p:sp>
+        <p:nvSpPr>
+          <p:cNvPr id="16" name="TextBox 15"/>
+          <p:cNvSpPr txBox="1"/>
+          <p:nvPr/>
+        </p:nvSpPr>
+        <p:spPr>
+          <a:xfrm>
+            <a:off x="640080" y="6080760"/>
+            <a:ext cx="10972800" cy="365760"/>
           </a:xfrm>
           <a:prstGeom prst="rect">
             <a:avLst/>
@@ -9554,347 +9693,13 @@
           <a:p>
             <a:pPr algn="ctr"/>
             <a:r>
-              <a:rPr sz="1800" b="1" i="0">
-                <a:solidFill>
-                  <a:srgbClr val="FFFFFF"/>
-                </a:solidFill>
-                <a:latin typeface="Helvetica"/>
-              </a:rPr>
-              <a:t>1</a:t>
-            </a:r>
-          </a:p>
-        </p:txBody>
-      </p:sp>
-      <p:sp>
-        <p:nvSpPr>
-          <p:cNvPr id="8" name="TextBox 7"/>
-          <p:cNvSpPr txBox="1"/>
-          <p:nvPr/>
-        </p:nvSpPr>
-        <p:spPr>
-          <a:xfrm>
-            <a:off x="1417320" y="2331720"/>
-            <a:ext cx="2743200" cy="548640"/>
-          </a:xfrm>
-          <a:prstGeom prst="rect">
-            <a:avLst/>
-          </a:prstGeom>
-          <a:noFill/>
-        </p:spPr>
-        <p:txBody>
-          <a:bodyPr wrap="square" lIns="0" rIns="0" tIns="0" bIns="0" anchor="t">
-            <a:spAutoFit/>
-          </a:bodyPr>
-          <a:lstStyle/>
-          <a:p>
-            <a:pPr algn="l"/>
-            <a:r>
-              <a:rPr sz="1400" b="1" i="0">
-                <a:solidFill>
-                  <a:srgbClr val="1A1A2E"/>
-                </a:solidFill>
-                <a:latin typeface="Helvetica"/>
-              </a:rPr>
-              <a:t>Train with P2, infer without</a:t>
-            </a:r>
-          </a:p>
-        </p:txBody>
-      </p:sp>
-      <p:sp>
-        <p:nvSpPr>
-          <p:cNvPr id="9" name="TextBox 8"/>
-          <p:cNvSpPr txBox="1"/>
-          <p:nvPr/>
-        </p:nvSpPr>
-        <p:spPr>
-          <a:xfrm>
-            <a:off x="822960" y="2971800"/>
-            <a:ext cx="3291840" cy="365760"/>
-          </a:xfrm>
-          <a:prstGeom prst="rect">
-            <a:avLst/>
-          </a:prstGeom>
-          <a:noFill/>
-        </p:spPr>
-        <p:txBody>
-          <a:bodyPr wrap="square" lIns="0" rIns="0" tIns="0" bIns="0" anchor="t">
-            <a:spAutoFit/>
-          </a:bodyPr>
-          <a:lstStyle/>
-          <a:p>
-            <a:pPr algn="l"/>
-            <a:r>
-              <a:rPr sz="1000" b="1" i="1">
-                <a:solidFill>
-                  <a:srgbClr val="1F6FEB"/>
-                </a:solidFill>
-                <a:latin typeface="Helvetica"/>
-              </a:rPr>
-              <a:t>fastest path</a:t>
-            </a:r>
-          </a:p>
-        </p:txBody>
-      </p:sp>
-      <p:sp>
-        <p:nvSpPr>
-          <p:cNvPr id="10" name="TextBox 9"/>
-          <p:cNvSpPr txBox="1"/>
-          <p:nvPr/>
-        </p:nvSpPr>
-        <p:spPr>
-          <a:xfrm>
-            <a:off x="822960" y="3429000"/>
-            <a:ext cx="3291840" cy="365760"/>
-          </a:xfrm>
-          <a:prstGeom prst="rect">
-            <a:avLst/>
-          </a:prstGeom>
-          <a:noFill/>
-        </p:spPr>
-        <p:txBody>
-          <a:bodyPr wrap="square" lIns="0" rIns="0" tIns="0" bIns="0" anchor="t">
-            <a:spAutoFit/>
-          </a:bodyPr>
-          <a:lstStyle/>
-          <a:p>
-            <a:pPr algn="l"/>
-            <a:r>
-              <a:rPr sz="1100" b="1" i="0">
-                <a:solidFill>
-                  <a:srgbClr val="1F6FEB"/>
-                </a:solidFill>
-                <a:latin typeface="Helvetica"/>
-              </a:rPr>
-              <a:t>How</a:t>
-            </a:r>
-          </a:p>
-        </p:txBody>
-      </p:sp>
-      <p:sp>
-        <p:nvSpPr>
-          <p:cNvPr id="11" name="TextBox 10"/>
-          <p:cNvSpPr txBox="1"/>
-          <p:nvPr/>
-        </p:nvSpPr>
-        <p:spPr>
-          <a:xfrm>
-            <a:off x="822960" y="3749039"/>
-            <a:ext cx="3291840" cy="1280160"/>
-          </a:xfrm>
-          <a:prstGeom prst="rect">
-            <a:avLst/>
-          </a:prstGeom>
-          <a:noFill/>
-        </p:spPr>
-        <p:txBody>
-          <a:bodyPr wrap="square" lIns="0" rIns="0" tIns="0" bIns="0" anchor="t">
-            <a:spAutoFit/>
-          </a:bodyPr>
-          <a:lstStyle/>
-          <a:p>
-            <a:pPr algn="l"/>
-            <a:r>
-              <a:rPr sz="1100" b="0" i="0">
-                <a:solidFill>
-                  <a:srgbClr val="1A1A2E"/>
-                </a:solidFill>
-                <a:latin typeface="Helvetica"/>
-              </a:rPr>
-              <a:t>Use P2 during training to improve small-object learning, then remove it at inference.</a:t>
-            </a:r>
-          </a:p>
-        </p:txBody>
-      </p:sp>
-      <p:sp>
-        <p:nvSpPr>
-          <p:cNvPr id="12" name="TextBox 11"/>
-          <p:cNvSpPr txBox="1"/>
-          <p:nvPr/>
-        </p:nvSpPr>
-        <p:spPr>
-          <a:xfrm>
-            <a:off x="822960" y="4846320"/>
-            <a:ext cx="3291840" cy="365760"/>
-          </a:xfrm>
-          <a:prstGeom prst="rect">
-            <a:avLst/>
-          </a:prstGeom>
-          <a:noFill/>
-        </p:spPr>
-        <p:txBody>
-          <a:bodyPr wrap="square" lIns="0" rIns="0" tIns="0" bIns="0" anchor="t">
-            <a:spAutoFit/>
-          </a:bodyPr>
-          <a:lstStyle/>
-          <a:p>
-            <a:pPr algn="l"/>
-            <a:r>
-              <a:rPr sz="1100" b="1" i="0">
-                <a:solidFill>
-                  <a:srgbClr val="2CA02C"/>
-                </a:solidFill>
-                <a:latin typeface="Helvetica"/>
-              </a:rPr>
-              <a:t>Goal</a:t>
-            </a:r>
-          </a:p>
-        </p:txBody>
-      </p:sp>
-      <p:sp>
-        <p:nvSpPr>
-          <p:cNvPr id="13" name="TextBox 12"/>
-          <p:cNvSpPr txBox="1"/>
-          <p:nvPr/>
-        </p:nvSpPr>
-        <p:spPr>
-          <a:xfrm>
-            <a:off x="822960" y="5166360"/>
-            <a:ext cx="3291840" cy="1280160"/>
-          </a:xfrm>
-          <a:prstGeom prst="rect">
-            <a:avLst/>
-          </a:prstGeom>
-          <a:noFill/>
-        </p:spPr>
-        <p:txBody>
-          <a:bodyPr wrap="square" lIns="0" rIns="0" tIns="0" bIns="0" anchor="t">
-            <a:spAutoFit/>
-          </a:bodyPr>
-          <a:lstStyle/>
-          <a:p>
-            <a:pPr algn="l"/>
-            <a:r>
-              <a:rPr sz="1100" b="0" i="0">
-                <a:solidFill>
-                  <a:srgbClr val="1A1A2E"/>
-                </a:solidFill>
-                <a:latin typeface="Helvetica"/>
-              </a:rPr>
-              <a:t>Keep most of the +0.99 small-object AP gain without the P2 computational cost.</a:t>
-            </a:r>
-          </a:p>
-        </p:txBody>
-      </p:sp>
-      <p:sp>
-        <p:nvSpPr>
-          <p:cNvPr id="14" name="Rounded Rectangle 13"/>
-          <p:cNvSpPr/>
-          <p:nvPr/>
-        </p:nvSpPr>
-        <p:spPr>
-          <a:xfrm>
-            <a:off x="4434840" y="2194560"/>
-            <a:ext cx="3657600" cy="3657600"/>
-          </a:xfrm>
-          <a:prstGeom prst="roundRect">
-            <a:avLst/>
-          </a:prstGeom>
-          <a:solidFill>
-            <a:srgbClr val="F0F6FF"/>
-          </a:solidFill>
-          <a:ln w="15240">
-            <a:solidFill>
-              <a:srgbClr val="1F6FEB"/>
-            </a:solidFill>
-          </a:ln>
-          <a:effectLst/>
-        </p:spPr>
-        <p:style>
-          <a:lnRef idx="1">
-            <a:schemeClr val="accent1"/>
-          </a:lnRef>
-          <a:fillRef idx="3">
-            <a:schemeClr val="accent1"/>
-          </a:fillRef>
-          <a:effectRef idx="2">
-            <a:schemeClr val="accent1"/>
-          </a:effectRef>
-          <a:fontRef idx="minor">
-            <a:schemeClr val="lt1"/>
-          </a:fontRef>
-        </p:style>
-        <p:txBody>
-          <a:bodyPr rtlCol="0" anchor="ctr"/>
-          <a:lstStyle/>
-          <a:p>
-            <a:pPr algn="ctr"/>
-          </a:p>
-        </p:txBody>
-      </p:sp>
-      <p:sp>
-        <p:nvSpPr>
-          <p:cNvPr id="15" name="Oval 14"/>
-          <p:cNvSpPr/>
-          <p:nvPr/>
-        </p:nvSpPr>
-        <p:spPr>
-          <a:xfrm>
-            <a:off x="4617720" y="2331720"/>
-            <a:ext cx="457200" cy="457200"/>
-          </a:xfrm>
-          <a:prstGeom prst="ellipse">
-            <a:avLst/>
-          </a:prstGeom>
-          <a:solidFill>
-            <a:srgbClr val="1F6FEB"/>
-          </a:solidFill>
-          <a:ln>
-            <a:noFill/>
-          </a:ln>
-        </p:spPr>
-        <p:style>
-          <a:lnRef idx="1">
-            <a:schemeClr val="accent1"/>
-          </a:lnRef>
-          <a:fillRef idx="3">
-            <a:schemeClr val="accent1"/>
-          </a:fillRef>
-          <a:effectRef idx="2">
-            <a:schemeClr val="accent1"/>
-          </a:effectRef>
-          <a:fontRef idx="minor">
-            <a:schemeClr val="lt1"/>
-          </a:fontRef>
-        </p:style>
-        <p:txBody>
-          <a:bodyPr rtlCol="0" anchor="ctr"/>
-          <a:lstStyle/>
-          <a:p>
-            <a:pPr algn="ctr"/>
-          </a:p>
-        </p:txBody>
-      </p:sp>
-      <p:sp>
-        <p:nvSpPr>
-          <p:cNvPr id="16" name="TextBox 15"/>
-          <p:cNvSpPr txBox="1"/>
-          <p:nvPr/>
-        </p:nvSpPr>
-        <p:spPr>
-          <a:xfrm>
-            <a:off x="4617720" y="2359152"/>
-            <a:ext cx="457200" cy="457200"/>
-          </a:xfrm>
-          <a:prstGeom prst="rect">
-            <a:avLst/>
-          </a:prstGeom>
-          <a:noFill/>
-        </p:spPr>
-        <p:txBody>
-          <a:bodyPr wrap="square" lIns="0" rIns="0" tIns="0" bIns="0" anchor="t">
-            <a:spAutoFit/>
-          </a:bodyPr>
-          <a:lstStyle/>
-          <a:p>
-            <a:pPr algn="ctr"/>
-            <a:r>
-              <a:rPr sz="1800" b="1" i="0">
-                <a:solidFill>
-                  <a:srgbClr val="FFFFFF"/>
-                </a:solidFill>
-                <a:latin typeface="Helvetica"/>
-              </a:rPr>
-              <a:t>2</a:t>
+              <a:rPr sz="1200" b="0" i="1">
+                <a:solidFill>
+                  <a:srgbClr val="666677"/>
+                </a:solidFill>
+                <a:latin typeface="Helvetica"/>
+              </a:rPr>
+              <a:t>Strong on accuracy; pays in inference speed. The next slide proposes a way to recover speed.</a:t>
             </a:r>
           </a:p>
         </p:txBody>
@@ -9902,585 +9707,6 @@
       <p:sp>
         <p:nvSpPr>
           <p:cNvPr id="17" name="TextBox 16"/>
-          <p:cNvSpPr txBox="1"/>
-          <p:nvPr/>
-        </p:nvSpPr>
-        <p:spPr>
-          <a:xfrm>
-            <a:off x="5212080" y="2331720"/>
-            <a:ext cx="2743200" cy="548640"/>
-          </a:xfrm>
-          <a:prstGeom prst="rect">
-            <a:avLst/>
-          </a:prstGeom>
-          <a:noFill/>
-        </p:spPr>
-        <p:txBody>
-          <a:bodyPr wrap="square" lIns="0" rIns="0" tIns="0" bIns="0" anchor="t">
-            <a:spAutoFit/>
-          </a:bodyPr>
-          <a:lstStyle/>
-          <a:p>
-            <a:pPr algn="l"/>
-            <a:r>
-              <a:rPr sz="1400" b="1" i="0">
-                <a:solidFill>
-                  <a:srgbClr val="1A1A2E"/>
-                </a:solidFill>
-                <a:latin typeface="Helvetica"/>
-              </a:rPr>
-              <a:t>Lighter P2 path</a:t>
-            </a:r>
-          </a:p>
-        </p:txBody>
-      </p:sp>
-      <p:sp>
-        <p:nvSpPr>
-          <p:cNvPr id="18" name="TextBox 17"/>
-          <p:cNvSpPr txBox="1"/>
-          <p:nvPr/>
-        </p:nvSpPr>
-        <p:spPr>
-          <a:xfrm>
-            <a:off x="4617720" y="2971800"/>
-            <a:ext cx="3291840" cy="365760"/>
-          </a:xfrm>
-          <a:prstGeom prst="rect">
-            <a:avLst/>
-          </a:prstGeom>
-          <a:noFill/>
-        </p:spPr>
-        <p:txBody>
-          <a:bodyPr wrap="square" lIns="0" rIns="0" tIns="0" bIns="0" anchor="t">
-            <a:spAutoFit/>
-          </a:bodyPr>
-          <a:lstStyle/>
-          <a:p>
-            <a:pPr algn="l"/>
-            <a:r>
-              <a:rPr sz="1000" b="1" i="1">
-                <a:solidFill>
-                  <a:srgbClr val="1F6FEB"/>
-                </a:solidFill>
-                <a:latin typeface="Helvetica"/>
-              </a:rPr>
-              <a:t>compromise</a:t>
-            </a:r>
-          </a:p>
-        </p:txBody>
-      </p:sp>
-      <p:sp>
-        <p:nvSpPr>
-          <p:cNvPr id="19" name="TextBox 18"/>
-          <p:cNvSpPr txBox="1"/>
-          <p:nvPr/>
-        </p:nvSpPr>
-        <p:spPr>
-          <a:xfrm>
-            <a:off x="4617720" y="3429000"/>
-            <a:ext cx="3291840" cy="365760"/>
-          </a:xfrm>
-          <a:prstGeom prst="rect">
-            <a:avLst/>
-          </a:prstGeom>
-          <a:noFill/>
-        </p:spPr>
-        <p:txBody>
-          <a:bodyPr wrap="square" lIns="0" rIns="0" tIns="0" bIns="0" anchor="t">
-            <a:spAutoFit/>
-          </a:bodyPr>
-          <a:lstStyle/>
-          <a:p>
-            <a:pPr algn="l"/>
-            <a:r>
-              <a:rPr sz="1100" b="1" i="0">
-                <a:solidFill>
-                  <a:srgbClr val="1F6FEB"/>
-                </a:solidFill>
-                <a:latin typeface="Helvetica"/>
-              </a:rPr>
-              <a:t>How</a:t>
-            </a:r>
-          </a:p>
-        </p:txBody>
-      </p:sp>
-      <p:sp>
-        <p:nvSpPr>
-          <p:cNvPr id="20" name="TextBox 19"/>
-          <p:cNvSpPr txBox="1"/>
-          <p:nvPr/>
-        </p:nvSpPr>
-        <p:spPr>
-          <a:xfrm>
-            <a:off x="4617720" y="3749039"/>
-            <a:ext cx="3291840" cy="1280160"/>
-          </a:xfrm>
-          <a:prstGeom prst="rect">
-            <a:avLst/>
-          </a:prstGeom>
-          <a:noFill/>
-        </p:spPr>
-        <p:txBody>
-          <a:bodyPr wrap="square" lIns="0" rIns="0" tIns="0" bIns="0" anchor="t">
-            <a:spAutoFit/>
-          </a:bodyPr>
-          <a:lstStyle/>
-          <a:p>
-            <a:pPr algn="l"/>
-            <a:r>
-              <a:rPr sz="1100" b="0" i="0">
-                <a:solidFill>
-                  <a:srgbClr val="1A1A2E"/>
-                </a:solidFill>
-                <a:latin typeface="Helvetica"/>
-              </a:rPr>
-              <a:t>Reduce the cost of P2 — fewer channels, or a simpler projection layer.</a:t>
-            </a:r>
-          </a:p>
-        </p:txBody>
-      </p:sp>
-      <p:sp>
-        <p:nvSpPr>
-          <p:cNvPr id="21" name="TextBox 20"/>
-          <p:cNvSpPr txBox="1"/>
-          <p:nvPr/>
-        </p:nvSpPr>
-        <p:spPr>
-          <a:xfrm>
-            <a:off x="4617720" y="4846320"/>
-            <a:ext cx="3291840" cy="365760"/>
-          </a:xfrm>
-          <a:prstGeom prst="rect">
-            <a:avLst/>
-          </a:prstGeom>
-          <a:noFill/>
-        </p:spPr>
-        <p:txBody>
-          <a:bodyPr wrap="square" lIns="0" rIns="0" tIns="0" bIns="0" anchor="t">
-            <a:spAutoFit/>
-          </a:bodyPr>
-          <a:lstStyle/>
-          <a:p>
-            <a:pPr algn="l"/>
-            <a:r>
-              <a:rPr sz="1100" b="1" i="0">
-                <a:solidFill>
-                  <a:srgbClr val="2CA02C"/>
-                </a:solidFill>
-                <a:latin typeface="Helvetica"/>
-              </a:rPr>
-              <a:t>Goal</a:t>
-            </a:r>
-          </a:p>
-        </p:txBody>
-      </p:sp>
-      <p:sp>
-        <p:nvSpPr>
-          <p:cNvPr id="22" name="TextBox 21"/>
-          <p:cNvSpPr txBox="1"/>
-          <p:nvPr/>
-        </p:nvSpPr>
-        <p:spPr>
-          <a:xfrm>
-            <a:off x="4617720" y="5166360"/>
-            <a:ext cx="3291840" cy="1280160"/>
-          </a:xfrm>
-          <a:prstGeom prst="rect">
-            <a:avLst/>
-          </a:prstGeom>
-          <a:noFill/>
-        </p:spPr>
-        <p:txBody>
-          <a:bodyPr wrap="square" lIns="0" rIns="0" tIns="0" bIns="0" anchor="t">
-            <a:spAutoFit/>
-          </a:bodyPr>
-          <a:lstStyle/>
-          <a:p>
-            <a:pPr algn="l"/>
-            <a:r>
-              <a:rPr sz="1100" b="0" i="0">
-                <a:solidFill>
-                  <a:srgbClr val="1A1A2E"/>
-                </a:solidFill>
-                <a:latin typeface="Helvetica"/>
-              </a:rPr>
-              <a:t>Preserve small-object improvements while reducing the high-resolution P2 slowdown.</a:t>
-            </a:r>
-          </a:p>
-        </p:txBody>
-      </p:sp>
-      <p:sp>
-        <p:nvSpPr>
-          <p:cNvPr id="23" name="Rounded Rectangle 22"/>
-          <p:cNvSpPr/>
-          <p:nvPr/>
-        </p:nvSpPr>
-        <p:spPr>
-          <a:xfrm>
-            <a:off x="8229600" y="2194560"/>
-            <a:ext cx="3657600" cy="3657600"/>
-          </a:xfrm>
-          <a:prstGeom prst="roundRect">
-            <a:avLst/>
-          </a:prstGeom>
-          <a:solidFill>
-            <a:srgbClr val="F0F6FF"/>
-          </a:solidFill>
-          <a:ln w="15240">
-            <a:solidFill>
-              <a:srgbClr val="1F6FEB"/>
-            </a:solidFill>
-          </a:ln>
-          <a:effectLst/>
-        </p:spPr>
-        <p:style>
-          <a:lnRef idx="1">
-            <a:schemeClr val="accent1"/>
-          </a:lnRef>
-          <a:fillRef idx="3">
-            <a:schemeClr val="accent1"/>
-          </a:fillRef>
-          <a:effectRef idx="2">
-            <a:schemeClr val="accent1"/>
-          </a:effectRef>
-          <a:fontRef idx="minor">
-            <a:schemeClr val="lt1"/>
-          </a:fontRef>
-        </p:style>
-        <p:txBody>
-          <a:bodyPr rtlCol="0" anchor="ctr"/>
-          <a:lstStyle/>
-          <a:p>
-            <a:pPr algn="ctr"/>
-          </a:p>
-        </p:txBody>
-      </p:sp>
-      <p:sp>
-        <p:nvSpPr>
-          <p:cNvPr id="24" name="Oval 23"/>
-          <p:cNvSpPr/>
-          <p:nvPr/>
-        </p:nvSpPr>
-        <p:spPr>
-          <a:xfrm>
-            <a:off x="8412480" y="2331720"/>
-            <a:ext cx="457200" cy="457200"/>
-          </a:xfrm>
-          <a:prstGeom prst="ellipse">
-            <a:avLst/>
-          </a:prstGeom>
-          <a:solidFill>
-            <a:srgbClr val="1F6FEB"/>
-          </a:solidFill>
-          <a:ln>
-            <a:noFill/>
-          </a:ln>
-        </p:spPr>
-        <p:style>
-          <a:lnRef idx="1">
-            <a:schemeClr val="accent1"/>
-          </a:lnRef>
-          <a:fillRef idx="3">
-            <a:schemeClr val="accent1"/>
-          </a:fillRef>
-          <a:effectRef idx="2">
-            <a:schemeClr val="accent1"/>
-          </a:effectRef>
-          <a:fontRef idx="minor">
-            <a:schemeClr val="lt1"/>
-          </a:fontRef>
-        </p:style>
-        <p:txBody>
-          <a:bodyPr rtlCol="0" anchor="ctr"/>
-          <a:lstStyle/>
-          <a:p>
-            <a:pPr algn="ctr"/>
-          </a:p>
-        </p:txBody>
-      </p:sp>
-      <p:sp>
-        <p:nvSpPr>
-          <p:cNvPr id="25" name="TextBox 24"/>
-          <p:cNvSpPr txBox="1"/>
-          <p:nvPr/>
-        </p:nvSpPr>
-        <p:spPr>
-          <a:xfrm>
-            <a:off x="8412480" y="2359152"/>
-            <a:ext cx="457200" cy="457200"/>
-          </a:xfrm>
-          <a:prstGeom prst="rect">
-            <a:avLst/>
-          </a:prstGeom>
-          <a:noFill/>
-        </p:spPr>
-        <p:txBody>
-          <a:bodyPr wrap="square" lIns="0" rIns="0" tIns="0" bIns="0" anchor="t">
-            <a:spAutoFit/>
-          </a:bodyPr>
-          <a:lstStyle/>
-          <a:p>
-            <a:pPr algn="ctr"/>
-            <a:r>
-              <a:rPr sz="1800" b="1" i="0">
-                <a:solidFill>
-                  <a:srgbClr val="FFFFFF"/>
-                </a:solidFill>
-                <a:latin typeface="Helvetica"/>
-              </a:rPr>
-              <a:t>3</a:t>
-            </a:r>
-          </a:p>
-        </p:txBody>
-      </p:sp>
-      <p:sp>
-        <p:nvSpPr>
-          <p:cNvPr id="26" name="TextBox 25"/>
-          <p:cNvSpPr txBox="1"/>
-          <p:nvPr/>
-        </p:nvSpPr>
-        <p:spPr>
-          <a:xfrm>
-            <a:off x="9006840" y="2331720"/>
-            <a:ext cx="2743200" cy="548640"/>
-          </a:xfrm>
-          <a:prstGeom prst="rect">
-            <a:avLst/>
-          </a:prstGeom>
-          <a:noFill/>
-        </p:spPr>
-        <p:txBody>
-          <a:bodyPr wrap="square" lIns="0" rIns="0" tIns="0" bIns="0" anchor="t">
-            <a:spAutoFit/>
-          </a:bodyPr>
-          <a:lstStyle/>
-          <a:p>
-            <a:pPr algn="l"/>
-            <a:r>
-              <a:rPr sz="1400" b="1" i="0">
-                <a:solidFill>
-                  <a:srgbClr val="1A1A2E"/>
-                </a:solidFill>
-                <a:latin typeface="Helvetica"/>
-              </a:rPr>
-              <a:t>Knowledge distillation</a:t>
-            </a:r>
-          </a:p>
-        </p:txBody>
-      </p:sp>
-      <p:sp>
-        <p:nvSpPr>
-          <p:cNvPr id="27" name="TextBox 26"/>
-          <p:cNvSpPr txBox="1"/>
-          <p:nvPr/>
-        </p:nvSpPr>
-        <p:spPr>
-          <a:xfrm>
-            <a:off x="8412480" y="2971800"/>
-            <a:ext cx="3291840" cy="365760"/>
-          </a:xfrm>
-          <a:prstGeom prst="rect">
-            <a:avLst/>
-          </a:prstGeom>
-          <a:noFill/>
-        </p:spPr>
-        <p:txBody>
-          <a:bodyPr wrap="square" lIns="0" rIns="0" tIns="0" bIns="0" anchor="t">
-            <a:spAutoFit/>
-          </a:bodyPr>
-          <a:lstStyle/>
-          <a:p>
-            <a:pPr algn="l"/>
-            <a:r>
-              <a:rPr sz="1000" b="1" i="1">
-                <a:solidFill>
-                  <a:srgbClr val="1F6FEB"/>
-                </a:solidFill>
-                <a:latin typeface="Helvetica"/>
-              </a:rPr>
-              <a:t>principled</a:t>
-            </a:r>
-          </a:p>
-        </p:txBody>
-      </p:sp>
-      <p:sp>
-        <p:nvSpPr>
-          <p:cNvPr id="28" name="TextBox 27"/>
-          <p:cNvSpPr txBox="1"/>
-          <p:nvPr/>
-        </p:nvSpPr>
-        <p:spPr>
-          <a:xfrm>
-            <a:off x="8412480" y="3429000"/>
-            <a:ext cx="3291840" cy="365760"/>
-          </a:xfrm>
-          <a:prstGeom prst="rect">
-            <a:avLst/>
-          </a:prstGeom>
-          <a:noFill/>
-        </p:spPr>
-        <p:txBody>
-          <a:bodyPr wrap="square" lIns="0" rIns="0" tIns="0" bIns="0" anchor="t">
-            <a:spAutoFit/>
-          </a:bodyPr>
-          <a:lstStyle/>
-          <a:p>
-            <a:pPr algn="l"/>
-            <a:r>
-              <a:rPr sz="1100" b="1" i="0">
-                <a:solidFill>
-                  <a:srgbClr val="1F6FEB"/>
-                </a:solidFill>
-                <a:latin typeface="Helvetica"/>
-              </a:rPr>
-              <a:t>How</a:t>
-            </a:r>
-          </a:p>
-        </p:txBody>
-      </p:sp>
-      <p:sp>
-        <p:nvSpPr>
-          <p:cNvPr id="29" name="TextBox 28"/>
-          <p:cNvSpPr txBox="1"/>
-          <p:nvPr/>
-        </p:nvSpPr>
-        <p:spPr>
-          <a:xfrm>
-            <a:off x="8412480" y="3749039"/>
-            <a:ext cx="3291840" cy="1280160"/>
-          </a:xfrm>
-          <a:prstGeom prst="rect">
-            <a:avLst/>
-          </a:prstGeom>
-          <a:noFill/>
-        </p:spPr>
-        <p:txBody>
-          <a:bodyPr wrap="square" lIns="0" rIns="0" tIns="0" bIns="0" anchor="t">
-            <a:spAutoFit/>
-          </a:bodyPr>
-          <a:lstStyle/>
-          <a:p>
-            <a:pPr algn="l"/>
-            <a:r>
-              <a:rPr sz="1100" b="0" i="0">
-                <a:solidFill>
-                  <a:srgbClr val="1A1A2E"/>
-                </a:solidFill>
-                <a:latin typeface="Helvetica"/>
-              </a:rPr>
-              <a:t>Transfer v2's small-object improvements into a faster baseline RT-DETR student.</a:t>
-            </a:r>
-          </a:p>
-        </p:txBody>
-      </p:sp>
-      <p:sp>
-        <p:nvSpPr>
-          <p:cNvPr id="30" name="TextBox 29"/>
-          <p:cNvSpPr txBox="1"/>
-          <p:nvPr/>
-        </p:nvSpPr>
-        <p:spPr>
-          <a:xfrm>
-            <a:off x="8412480" y="4846320"/>
-            <a:ext cx="3291840" cy="365760"/>
-          </a:xfrm>
-          <a:prstGeom prst="rect">
-            <a:avLst/>
-          </a:prstGeom>
-          <a:noFill/>
-        </p:spPr>
-        <p:txBody>
-          <a:bodyPr wrap="square" lIns="0" rIns="0" tIns="0" bIns="0" anchor="t">
-            <a:spAutoFit/>
-          </a:bodyPr>
-          <a:lstStyle/>
-          <a:p>
-            <a:pPr algn="l"/>
-            <a:r>
-              <a:rPr sz="1100" b="1" i="0">
-                <a:solidFill>
-                  <a:srgbClr val="2CA02C"/>
-                </a:solidFill>
-                <a:latin typeface="Helvetica"/>
-              </a:rPr>
-              <a:t>Goal</a:t>
-            </a:r>
-          </a:p>
-        </p:txBody>
-      </p:sp>
-      <p:sp>
-        <p:nvSpPr>
-          <p:cNvPr id="31" name="TextBox 30"/>
-          <p:cNvSpPr txBox="1"/>
-          <p:nvPr/>
-        </p:nvSpPr>
-        <p:spPr>
-          <a:xfrm>
-            <a:off x="8412480" y="5166360"/>
-            <a:ext cx="3291840" cy="1280160"/>
-          </a:xfrm>
-          <a:prstGeom prst="rect">
-            <a:avLst/>
-          </a:prstGeom>
-          <a:noFill/>
-        </p:spPr>
-        <p:txBody>
-          <a:bodyPr wrap="square" lIns="0" rIns="0" tIns="0" bIns="0" anchor="t">
-            <a:spAutoFit/>
-          </a:bodyPr>
-          <a:lstStyle/>
-          <a:p>
-            <a:pPr algn="l"/>
-            <a:r>
-              <a:rPr sz="1100" b="0" i="0">
-                <a:solidFill>
-                  <a:srgbClr val="1A1A2E"/>
-                </a:solidFill>
-                <a:latin typeface="Helvetica"/>
-              </a:rPr>
-              <a:t>Recover baseline inference speed while retaining the small-object AP gains learned from P2 feedback.</a:t>
-            </a:r>
-          </a:p>
-        </p:txBody>
-      </p:sp>
-      <p:sp>
-        <p:nvSpPr>
-          <p:cNvPr id="32" name="TextBox 31"/>
-          <p:cNvSpPr txBox="1"/>
-          <p:nvPr/>
-        </p:nvSpPr>
-        <p:spPr>
-          <a:xfrm>
-            <a:off x="640080" y="6126480"/>
-            <a:ext cx="10972800" cy="365760"/>
-          </a:xfrm>
-          <a:prstGeom prst="rect">
-            <a:avLst/>
-          </a:prstGeom>
-          <a:noFill/>
-        </p:spPr>
-        <p:txBody>
-          <a:bodyPr wrap="square" lIns="0" rIns="0" tIns="0" bIns="0" anchor="t">
-            <a:spAutoFit/>
-          </a:bodyPr>
-          <a:lstStyle/>
-          <a:p>
-            <a:pPr algn="ctr"/>
-            <a:r>
-              <a:rPr sz="1300" b="1" i="0">
-                <a:solidFill>
-                  <a:srgbClr val="1F6FEB"/>
-                </a:solidFill>
-                <a:latin typeface="Helvetica"/>
-              </a:rPr>
-              <a:t>Common goal: keep the +0.99 small-object AP gain while approaching the 53 FPS baseline.</a:t>
-            </a:r>
-          </a:p>
-        </p:txBody>
-      </p:sp>
-      <p:sp>
-        <p:nvSpPr>
-          <p:cNvPr id="33" name="TextBox 32"/>
           <p:cNvSpPr txBox="1"/>
           <p:nvPr/>
         </p:nvSpPr>
@@ -10515,7 +9741,7 @@
       </p:sp>
       <p:sp>
         <p:nvSpPr>
-          <p:cNvPr id="34" name="TextBox 33"/>
+          <p:cNvPr id="18" name="TextBox 17"/>
           <p:cNvSpPr txBox="1"/>
           <p:nvPr/>
         </p:nvSpPr>
@@ -10543,7 +9769,7 @@
                 </a:solidFill>
                 <a:latin typeface="Helvetica"/>
               </a:rPr>
-              <a:t>24 / 27</a:t>
+              <a:t>24 / 28</a:t>
             </a:r>
           </a:p>
         </p:txBody>
@@ -10596,7 +9822,7 @@
                 </a:solidFill>
                 <a:latin typeface="Helvetica"/>
               </a:rPr>
-              <a:t>Conclusion</a:t>
+              <a:t>Future work: recovering inference speed</a:t>
             </a:r>
           </a:p>
         </p:txBody>
@@ -10646,14 +9872,95 @@
       </p:sp>
       <p:sp>
         <p:nvSpPr>
-          <p:cNvPr id="4" name="Oval 3"/>
+          <p:cNvPr id="4" name="TextBox 3"/>
+          <p:cNvSpPr txBox="1"/>
+          <p:nvPr/>
+        </p:nvSpPr>
+        <p:spPr>
+          <a:xfrm>
+            <a:off x="640080" y="1417320"/>
+            <a:ext cx="10972800" cy="457200"/>
+          </a:xfrm>
+          <a:prstGeom prst="rect">
+            <a:avLst/>
+          </a:prstGeom>
+          <a:noFill/>
+        </p:spPr>
+        <p:txBody>
+          <a:bodyPr wrap="square" lIns="0" rIns="0" tIns="0" bIns="0" anchor="t">
+            <a:spAutoFit/>
+          </a:bodyPr>
+          <a:lstStyle/>
+          <a:p>
+            <a:pPr algn="ctr"/>
+            <a:r>
+              <a:rPr sz="1800" b="0" i="1">
+                <a:solidFill>
+                  <a:srgbClr val="1A1A2E"/>
+                </a:solidFill>
+                <a:latin typeface="Helvetica"/>
+              </a:rPr>
+              <a:t>The 2× slowdown comes from the P2 level, not the feedback module.</a:t>
+            </a:r>
+          </a:p>
+        </p:txBody>
+      </p:sp>
+      <p:sp>
+        <p:nvSpPr>
+          <p:cNvPr id="5" name="Rounded Rectangle 4"/>
           <p:cNvSpPr/>
           <p:nvPr/>
         </p:nvSpPr>
         <p:spPr>
           <a:xfrm>
-            <a:off x="822960" y="1965960"/>
-            <a:ext cx="502920" cy="502920"/>
+            <a:off x="640080" y="2194560"/>
+            <a:ext cx="3657600" cy="3657600"/>
+          </a:xfrm>
+          <a:prstGeom prst="roundRect">
+            <a:avLst/>
+          </a:prstGeom>
+          <a:solidFill>
+            <a:srgbClr val="F0F6FF"/>
+          </a:solidFill>
+          <a:ln w="15240">
+            <a:solidFill>
+              <a:srgbClr val="1F6FEB"/>
+            </a:solidFill>
+          </a:ln>
+          <a:effectLst/>
+        </p:spPr>
+        <p:style>
+          <a:lnRef idx="1">
+            <a:schemeClr val="accent1"/>
+          </a:lnRef>
+          <a:fillRef idx="3">
+            <a:schemeClr val="accent1"/>
+          </a:fillRef>
+          <a:effectRef idx="2">
+            <a:schemeClr val="accent1"/>
+          </a:effectRef>
+          <a:fontRef idx="minor">
+            <a:schemeClr val="lt1"/>
+          </a:fontRef>
+        </p:style>
+        <p:txBody>
+          <a:bodyPr rtlCol="0" anchor="ctr"/>
+          <a:lstStyle/>
+          <a:p>
+            <a:pPr algn="ctr"/>
+          </a:p>
+        </p:txBody>
+      </p:sp>
+      <p:sp>
+        <p:nvSpPr>
+          <p:cNvPr id="6" name="Oval 5"/>
+          <p:cNvSpPr/>
+          <p:nvPr/>
+        </p:nvSpPr>
+        <p:spPr>
+          <a:xfrm>
+            <a:off x="822960" y="2331720"/>
+            <a:ext cx="457200" cy="457200"/>
           </a:xfrm>
           <a:prstGeom prst="ellipse">
             <a:avLst/>
@@ -10689,14 +9996,14 @@
       </p:sp>
       <p:sp>
         <p:nvSpPr>
-          <p:cNvPr id="5" name="TextBox 4"/>
-          <p:cNvSpPr txBox="1"/>
-          <p:nvPr/>
-        </p:nvSpPr>
-        <p:spPr>
-          <a:xfrm>
-            <a:off x="822960" y="1993392"/>
-            <a:ext cx="502920" cy="502920"/>
+          <p:cNvPr id="7" name="TextBox 6"/>
+          <p:cNvSpPr txBox="1"/>
+          <p:nvPr/>
+        </p:nvSpPr>
+        <p:spPr>
+          <a:xfrm>
+            <a:off x="822960" y="2359152"/>
+            <a:ext cx="457200" cy="457200"/>
           </a:xfrm>
           <a:prstGeom prst="rect">
             <a:avLst/>
@@ -10711,7 +10018,7 @@
           <a:p>
             <a:pPr algn="ctr"/>
             <a:r>
-              <a:rPr sz="2000" b="1" i="0">
+              <a:rPr sz="1800" b="1" i="0">
                 <a:solidFill>
                   <a:srgbClr val="FFFFFF"/>
                 </a:solidFill>
@@ -10724,14 +10031,14 @@
       </p:sp>
       <p:sp>
         <p:nvSpPr>
-          <p:cNvPr id="6" name="TextBox 5"/>
-          <p:cNvSpPr txBox="1"/>
-          <p:nvPr/>
-        </p:nvSpPr>
-        <p:spPr>
-          <a:xfrm>
-            <a:off x="1554480" y="1874520"/>
-            <a:ext cx="10058400" cy="548640"/>
+          <p:cNvPr id="8" name="TextBox 7"/>
+          <p:cNvSpPr txBox="1"/>
+          <p:nvPr/>
+        </p:nvSpPr>
+        <p:spPr>
+          <a:xfrm>
+            <a:off x="1417320" y="2331720"/>
+            <a:ext cx="2743200" cy="548640"/>
           </a:xfrm>
           <a:prstGeom prst="rect">
             <a:avLst/>
@@ -10746,27 +10053,27 @@
           <a:p>
             <a:pPr algn="l"/>
             <a:r>
-              <a:rPr sz="2400" b="1" i="0">
+              <a:rPr sz="1400" b="1" i="0">
                 <a:solidFill>
                   <a:srgbClr val="1A1A2E"/>
                 </a:solidFill>
                 <a:latin typeface="Helvetica"/>
               </a:rPr>
-              <a:t>Feedback improves small-object detection</a:t>
-            </a:r>
-          </a:p>
-        </p:txBody>
-      </p:sp>
-      <p:sp>
-        <p:nvSpPr>
-          <p:cNvPr id="7" name="TextBox 6"/>
-          <p:cNvSpPr txBox="1"/>
-          <p:nvPr/>
-        </p:nvSpPr>
-        <p:spPr>
-          <a:xfrm>
-            <a:off x="1554480" y="2468880"/>
-            <a:ext cx="10058400" cy="548640"/>
+              <a:t>Train with P2, infer without</a:t>
+            </a:r>
+          </a:p>
+        </p:txBody>
+      </p:sp>
+      <p:sp>
+        <p:nvSpPr>
+          <p:cNvPr id="9" name="TextBox 8"/>
+          <p:cNvSpPr txBox="1"/>
+          <p:nvPr/>
+        </p:nvSpPr>
+        <p:spPr>
+          <a:xfrm>
+            <a:off x="822960" y="2971800"/>
+            <a:ext cx="3291840" cy="365760"/>
           </a:xfrm>
           <a:prstGeom prst="rect">
             <a:avLst/>
@@ -10781,27 +10088,213 @@
           <a:p>
             <a:pPr algn="l"/>
             <a:r>
-              <a:rPr sz="1500" b="0" i="1">
-                <a:solidFill>
-                  <a:srgbClr val="666677"/>
-                </a:solidFill>
-                <a:latin typeface="Helvetica"/>
-              </a:rPr>
-              <a:t>+0.99 small-object AP, causal contribution at inference.</a:t>
-            </a:r>
-          </a:p>
-        </p:txBody>
-      </p:sp>
-      <p:sp>
-        <p:nvSpPr>
-          <p:cNvPr id="8" name="Oval 7"/>
+              <a:rPr sz="1000" b="1" i="1">
+                <a:solidFill>
+                  <a:srgbClr val="1F6FEB"/>
+                </a:solidFill>
+                <a:latin typeface="Helvetica"/>
+              </a:rPr>
+              <a:t>fastest path</a:t>
+            </a:r>
+          </a:p>
+        </p:txBody>
+      </p:sp>
+      <p:sp>
+        <p:nvSpPr>
+          <p:cNvPr id="10" name="TextBox 9"/>
+          <p:cNvSpPr txBox="1"/>
+          <p:nvPr/>
+        </p:nvSpPr>
+        <p:spPr>
+          <a:xfrm>
+            <a:off x="822960" y="3429000"/>
+            <a:ext cx="3291840" cy="365760"/>
+          </a:xfrm>
+          <a:prstGeom prst="rect">
+            <a:avLst/>
+          </a:prstGeom>
+          <a:noFill/>
+        </p:spPr>
+        <p:txBody>
+          <a:bodyPr wrap="square" lIns="0" rIns="0" tIns="0" bIns="0" anchor="t">
+            <a:spAutoFit/>
+          </a:bodyPr>
+          <a:lstStyle/>
+          <a:p>
+            <a:pPr algn="l"/>
+            <a:r>
+              <a:rPr sz="1100" b="1" i="0">
+                <a:solidFill>
+                  <a:srgbClr val="1F6FEB"/>
+                </a:solidFill>
+                <a:latin typeface="Helvetica"/>
+              </a:rPr>
+              <a:t>How</a:t>
+            </a:r>
+          </a:p>
+        </p:txBody>
+      </p:sp>
+      <p:sp>
+        <p:nvSpPr>
+          <p:cNvPr id="11" name="TextBox 10"/>
+          <p:cNvSpPr txBox="1"/>
+          <p:nvPr/>
+        </p:nvSpPr>
+        <p:spPr>
+          <a:xfrm>
+            <a:off x="822960" y="3749039"/>
+            <a:ext cx="3291840" cy="1280160"/>
+          </a:xfrm>
+          <a:prstGeom prst="rect">
+            <a:avLst/>
+          </a:prstGeom>
+          <a:noFill/>
+        </p:spPr>
+        <p:txBody>
+          <a:bodyPr wrap="square" lIns="0" rIns="0" tIns="0" bIns="0" anchor="t">
+            <a:spAutoFit/>
+          </a:bodyPr>
+          <a:lstStyle/>
+          <a:p>
+            <a:pPr algn="l"/>
+            <a:r>
+              <a:rPr sz="1100" b="0" i="0">
+                <a:solidFill>
+                  <a:srgbClr val="1A1A2E"/>
+                </a:solidFill>
+                <a:latin typeface="Helvetica"/>
+              </a:rPr>
+              <a:t>Use P2 during training to improve small-object learning, then remove it at inference.</a:t>
+            </a:r>
+          </a:p>
+        </p:txBody>
+      </p:sp>
+      <p:sp>
+        <p:nvSpPr>
+          <p:cNvPr id="12" name="TextBox 11"/>
+          <p:cNvSpPr txBox="1"/>
+          <p:nvPr/>
+        </p:nvSpPr>
+        <p:spPr>
+          <a:xfrm>
+            <a:off x="822960" y="4846320"/>
+            <a:ext cx="3291840" cy="365760"/>
+          </a:xfrm>
+          <a:prstGeom prst="rect">
+            <a:avLst/>
+          </a:prstGeom>
+          <a:noFill/>
+        </p:spPr>
+        <p:txBody>
+          <a:bodyPr wrap="square" lIns="0" rIns="0" tIns="0" bIns="0" anchor="t">
+            <a:spAutoFit/>
+          </a:bodyPr>
+          <a:lstStyle/>
+          <a:p>
+            <a:pPr algn="l"/>
+            <a:r>
+              <a:rPr sz="1100" b="1" i="0">
+                <a:solidFill>
+                  <a:srgbClr val="2CA02C"/>
+                </a:solidFill>
+                <a:latin typeface="Helvetica"/>
+              </a:rPr>
+              <a:t>Goal</a:t>
+            </a:r>
+          </a:p>
+        </p:txBody>
+      </p:sp>
+      <p:sp>
+        <p:nvSpPr>
+          <p:cNvPr id="13" name="TextBox 12"/>
+          <p:cNvSpPr txBox="1"/>
+          <p:nvPr/>
+        </p:nvSpPr>
+        <p:spPr>
+          <a:xfrm>
+            <a:off x="822960" y="5166360"/>
+            <a:ext cx="3291840" cy="1280160"/>
+          </a:xfrm>
+          <a:prstGeom prst="rect">
+            <a:avLst/>
+          </a:prstGeom>
+          <a:noFill/>
+        </p:spPr>
+        <p:txBody>
+          <a:bodyPr wrap="square" lIns="0" rIns="0" tIns="0" bIns="0" anchor="t">
+            <a:spAutoFit/>
+          </a:bodyPr>
+          <a:lstStyle/>
+          <a:p>
+            <a:pPr algn="l"/>
+            <a:r>
+              <a:rPr sz="1100" b="0" i="0">
+                <a:solidFill>
+                  <a:srgbClr val="1A1A2E"/>
+                </a:solidFill>
+                <a:latin typeface="Helvetica"/>
+              </a:rPr>
+              <a:t>Keep most of the +0.99 small-object AP gain without the P2 computational cost.</a:t>
+            </a:r>
+          </a:p>
+        </p:txBody>
+      </p:sp>
+      <p:sp>
+        <p:nvSpPr>
+          <p:cNvPr id="14" name="Rounded Rectangle 13"/>
           <p:cNvSpPr/>
           <p:nvPr/>
         </p:nvSpPr>
         <p:spPr>
           <a:xfrm>
-            <a:off x="822960" y="3383280"/>
-            <a:ext cx="502920" cy="502920"/>
+            <a:off x="4434840" y="2194560"/>
+            <a:ext cx="3657600" cy="3657600"/>
+          </a:xfrm>
+          <a:prstGeom prst="roundRect">
+            <a:avLst/>
+          </a:prstGeom>
+          <a:solidFill>
+            <a:srgbClr val="F0F6FF"/>
+          </a:solidFill>
+          <a:ln w="15240">
+            <a:solidFill>
+              <a:srgbClr val="1F6FEB"/>
+            </a:solidFill>
+          </a:ln>
+          <a:effectLst/>
+        </p:spPr>
+        <p:style>
+          <a:lnRef idx="1">
+            <a:schemeClr val="accent1"/>
+          </a:lnRef>
+          <a:fillRef idx="3">
+            <a:schemeClr val="accent1"/>
+          </a:fillRef>
+          <a:effectRef idx="2">
+            <a:schemeClr val="accent1"/>
+          </a:effectRef>
+          <a:fontRef idx="minor">
+            <a:schemeClr val="lt1"/>
+          </a:fontRef>
+        </p:style>
+        <p:txBody>
+          <a:bodyPr rtlCol="0" anchor="ctr"/>
+          <a:lstStyle/>
+          <a:p>
+            <a:pPr algn="ctr"/>
+          </a:p>
+        </p:txBody>
+      </p:sp>
+      <p:sp>
+        <p:nvSpPr>
+          <p:cNvPr id="15" name="Oval 14"/>
+          <p:cNvSpPr/>
+          <p:nvPr/>
+        </p:nvSpPr>
+        <p:spPr>
+          <a:xfrm>
+            <a:off x="4617720" y="2331720"/>
+            <a:ext cx="457200" cy="457200"/>
           </a:xfrm>
           <a:prstGeom prst="ellipse">
             <a:avLst/>
@@ -10837,14 +10330,14 @@
       </p:sp>
       <p:sp>
         <p:nvSpPr>
-          <p:cNvPr id="9" name="TextBox 8"/>
-          <p:cNvSpPr txBox="1"/>
-          <p:nvPr/>
-        </p:nvSpPr>
-        <p:spPr>
-          <a:xfrm>
-            <a:off x="822960" y="3410712"/>
-            <a:ext cx="502920" cy="502920"/>
+          <p:cNvPr id="16" name="TextBox 15"/>
+          <p:cNvSpPr txBox="1"/>
+          <p:nvPr/>
+        </p:nvSpPr>
+        <p:spPr>
+          <a:xfrm>
+            <a:off x="4617720" y="2359152"/>
+            <a:ext cx="457200" cy="457200"/>
           </a:xfrm>
           <a:prstGeom prst="rect">
             <a:avLst/>
@@ -10859,7 +10352,7 @@
           <a:p>
             <a:pPr algn="ctr"/>
             <a:r>
-              <a:rPr sz="2000" b="1" i="0">
+              <a:rPr sz="1800" b="1" i="0">
                 <a:solidFill>
                   <a:srgbClr val="FFFFFF"/>
                 </a:solidFill>
@@ -10872,14 +10365,14 @@
       </p:sp>
       <p:sp>
         <p:nvSpPr>
-          <p:cNvPr id="10" name="TextBox 9"/>
-          <p:cNvSpPr txBox="1"/>
-          <p:nvPr/>
-        </p:nvSpPr>
-        <p:spPr>
-          <a:xfrm>
-            <a:off x="1554480" y="3291840"/>
-            <a:ext cx="10058400" cy="548640"/>
+          <p:cNvPr id="17" name="TextBox 16"/>
+          <p:cNvSpPr txBox="1"/>
+          <p:nvPr/>
+        </p:nvSpPr>
+        <p:spPr>
+          <a:xfrm>
+            <a:off x="5212080" y="2331720"/>
+            <a:ext cx="2743200" cy="548640"/>
           </a:xfrm>
           <a:prstGeom prst="rect">
             <a:avLst/>
@@ -10894,27 +10387,27 @@
           <a:p>
             <a:pPr algn="l"/>
             <a:r>
-              <a:rPr sz="2400" b="1" i="0">
+              <a:rPr sz="1400" b="1" i="0">
                 <a:solidFill>
                   <a:srgbClr val="1A1A2E"/>
                 </a:solidFill>
                 <a:latin typeface="Helvetica"/>
               </a:rPr>
-              <a:t>Only works with proper design</a:t>
-            </a:r>
-          </a:p>
-        </p:txBody>
-      </p:sp>
-      <p:sp>
-        <p:nvSpPr>
-          <p:cNvPr id="11" name="TextBox 10"/>
-          <p:cNvSpPr txBox="1"/>
-          <p:nvPr/>
-        </p:nvSpPr>
-        <p:spPr>
-          <a:xfrm>
-            <a:off x="1554480" y="3886200"/>
-            <a:ext cx="10058400" cy="548640"/>
+              <a:t>Lighter P2 path</a:t>
+            </a:r>
+          </a:p>
+        </p:txBody>
+      </p:sp>
+      <p:sp>
+        <p:nvSpPr>
+          <p:cNvPr id="18" name="TextBox 17"/>
+          <p:cNvSpPr txBox="1"/>
+          <p:nvPr/>
+        </p:nvSpPr>
+        <p:spPr>
+          <a:xfrm>
+            <a:off x="4617720" y="2971800"/>
+            <a:ext cx="3291840" cy="365760"/>
           </a:xfrm>
           <a:prstGeom prst="rect">
             <a:avLst/>
@@ -10929,27 +10422,213 @@
           <a:p>
             <a:pPr algn="l"/>
             <a:r>
-              <a:rPr sz="1500" b="0" i="1">
-                <a:solidFill>
-                  <a:srgbClr val="666677"/>
-                </a:solidFill>
-                <a:latin typeface="Helvetica"/>
-              </a:rPr>
-              <a:t>Floor the gate; restrict to small-object levels.</a:t>
-            </a:r>
-          </a:p>
-        </p:txBody>
-      </p:sp>
-      <p:sp>
-        <p:nvSpPr>
-          <p:cNvPr id="12" name="Oval 11"/>
+              <a:rPr sz="1000" b="1" i="1">
+                <a:solidFill>
+                  <a:srgbClr val="1F6FEB"/>
+                </a:solidFill>
+                <a:latin typeface="Helvetica"/>
+              </a:rPr>
+              <a:t>compromise</a:t>
+            </a:r>
+          </a:p>
+        </p:txBody>
+      </p:sp>
+      <p:sp>
+        <p:nvSpPr>
+          <p:cNvPr id="19" name="TextBox 18"/>
+          <p:cNvSpPr txBox="1"/>
+          <p:nvPr/>
+        </p:nvSpPr>
+        <p:spPr>
+          <a:xfrm>
+            <a:off x="4617720" y="3429000"/>
+            <a:ext cx="3291840" cy="365760"/>
+          </a:xfrm>
+          <a:prstGeom prst="rect">
+            <a:avLst/>
+          </a:prstGeom>
+          <a:noFill/>
+        </p:spPr>
+        <p:txBody>
+          <a:bodyPr wrap="square" lIns="0" rIns="0" tIns="0" bIns="0" anchor="t">
+            <a:spAutoFit/>
+          </a:bodyPr>
+          <a:lstStyle/>
+          <a:p>
+            <a:pPr algn="l"/>
+            <a:r>
+              <a:rPr sz="1100" b="1" i="0">
+                <a:solidFill>
+                  <a:srgbClr val="1F6FEB"/>
+                </a:solidFill>
+                <a:latin typeface="Helvetica"/>
+              </a:rPr>
+              <a:t>How</a:t>
+            </a:r>
+          </a:p>
+        </p:txBody>
+      </p:sp>
+      <p:sp>
+        <p:nvSpPr>
+          <p:cNvPr id="20" name="TextBox 19"/>
+          <p:cNvSpPr txBox="1"/>
+          <p:nvPr/>
+        </p:nvSpPr>
+        <p:spPr>
+          <a:xfrm>
+            <a:off x="4617720" y="3749039"/>
+            <a:ext cx="3291840" cy="1280160"/>
+          </a:xfrm>
+          <a:prstGeom prst="rect">
+            <a:avLst/>
+          </a:prstGeom>
+          <a:noFill/>
+        </p:spPr>
+        <p:txBody>
+          <a:bodyPr wrap="square" lIns="0" rIns="0" tIns="0" bIns="0" anchor="t">
+            <a:spAutoFit/>
+          </a:bodyPr>
+          <a:lstStyle/>
+          <a:p>
+            <a:pPr algn="l"/>
+            <a:r>
+              <a:rPr sz="1100" b="0" i="0">
+                <a:solidFill>
+                  <a:srgbClr val="1A1A2E"/>
+                </a:solidFill>
+                <a:latin typeface="Helvetica"/>
+              </a:rPr>
+              <a:t>Reduce the cost of P2 — fewer channels, or a simpler projection layer.</a:t>
+            </a:r>
+          </a:p>
+        </p:txBody>
+      </p:sp>
+      <p:sp>
+        <p:nvSpPr>
+          <p:cNvPr id="21" name="TextBox 20"/>
+          <p:cNvSpPr txBox="1"/>
+          <p:nvPr/>
+        </p:nvSpPr>
+        <p:spPr>
+          <a:xfrm>
+            <a:off x="4617720" y="4846320"/>
+            <a:ext cx="3291840" cy="365760"/>
+          </a:xfrm>
+          <a:prstGeom prst="rect">
+            <a:avLst/>
+          </a:prstGeom>
+          <a:noFill/>
+        </p:spPr>
+        <p:txBody>
+          <a:bodyPr wrap="square" lIns="0" rIns="0" tIns="0" bIns="0" anchor="t">
+            <a:spAutoFit/>
+          </a:bodyPr>
+          <a:lstStyle/>
+          <a:p>
+            <a:pPr algn="l"/>
+            <a:r>
+              <a:rPr sz="1100" b="1" i="0">
+                <a:solidFill>
+                  <a:srgbClr val="2CA02C"/>
+                </a:solidFill>
+                <a:latin typeface="Helvetica"/>
+              </a:rPr>
+              <a:t>Goal</a:t>
+            </a:r>
+          </a:p>
+        </p:txBody>
+      </p:sp>
+      <p:sp>
+        <p:nvSpPr>
+          <p:cNvPr id="22" name="TextBox 21"/>
+          <p:cNvSpPr txBox="1"/>
+          <p:nvPr/>
+        </p:nvSpPr>
+        <p:spPr>
+          <a:xfrm>
+            <a:off x="4617720" y="5166360"/>
+            <a:ext cx="3291840" cy="1280160"/>
+          </a:xfrm>
+          <a:prstGeom prst="rect">
+            <a:avLst/>
+          </a:prstGeom>
+          <a:noFill/>
+        </p:spPr>
+        <p:txBody>
+          <a:bodyPr wrap="square" lIns="0" rIns="0" tIns="0" bIns="0" anchor="t">
+            <a:spAutoFit/>
+          </a:bodyPr>
+          <a:lstStyle/>
+          <a:p>
+            <a:pPr algn="l"/>
+            <a:r>
+              <a:rPr sz="1100" b="0" i="0">
+                <a:solidFill>
+                  <a:srgbClr val="1A1A2E"/>
+                </a:solidFill>
+                <a:latin typeface="Helvetica"/>
+              </a:rPr>
+              <a:t>Preserve small-object improvements while reducing the high-resolution P2 slowdown.</a:t>
+            </a:r>
+          </a:p>
+        </p:txBody>
+      </p:sp>
+      <p:sp>
+        <p:nvSpPr>
+          <p:cNvPr id="23" name="Rounded Rectangle 22"/>
           <p:cNvSpPr/>
           <p:nvPr/>
         </p:nvSpPr>
         <p:spPr>
           <a:xfrm>
-            <a:off x="822960" y="4800600"/>
-            <a:ext cx="502920" cy="502920"/>
+            <a:off x="8229600" y="2194560"/>
+            <a:ext cx="3657600" cy="3657600"/>
+          </a:xfrm>
+          <a:prstGeom prst="roundRect">
+            <a:avLst/>
+          </a:prstGeom>
+          <a:solidFill>
+            <a:srgbClr val="F0F6FF"/>
+          </a:solidFill>
+          <a:ln w="15240">
+            <a:solidFill>
+              <a:srgbClr val="1F6FEB"/>
+            </a:solidFill>
+          </a:ln>
+          <a:effectLst/>
+        </p:spPr>
+        <p:style>
+          <a:lnRef idx="1">
+            <a:schemeClr val="accent1"/>
+          </a:lnRef>
+          <a:fillRef idx="3">
+            <a:schemeClr val="accent1"/>
+          </a:fillRef>
+          <a:effectRef idx="2">
+            <a:schemeClr val="accent1"/>
+          </a:effectRef>
+          <a:fontRef idx="minor">
+            <a:schemeClr val="lt1"/>
+          </a:fontRef>
+        </p:style>
+        <p:txBody>
+          <a:bodyPr rtlCol="0" anchor="ctr"/>
+          <a:lstStyle/>
+          <a:p>
+            <a:pPr algn="ctr"/>
+          </a:p>
+        </p:txBody>
+      </p:sp>
+      <p:sp>
+        <p:nvSpPr>
+          <p:cNvPr id="24" name="Oval 23"/>
+          <p:cNvSpPr/>
+          <p:nvPr/>
+        </p:nvSpPr>
+        <p:spPr>
+          <a:xfrm>
+            <a:off x="8412480" y="2331720"/>
+            <a:ext cx="457200" cy="457200"/>
           </a:xfrm>
           <a:prstGeom prst="ellipse">
             <a:avLst/>
@@ -10985,14 +10664,14 @@
       </p:sp>
       <p:sp>
         <p:nvSpPr>
-          <p:cNvPr id="13" name="TextBox 12"/>
-          <p:cNvSpPr txBox="1"/>
-          <p:nvPr/>
-        </p:nvSpPr>
-        <p:spPr>
-          <a:xfrm>
-            <a:off x="822960" y="4828032"/>
-            <a:ext cx="502920" cy="502920"/>
+          <p:cNvPr id="25" name="TextBox 24"/>
+          <p:cNvSpPr txBox="1"/>
+          <p:nvPr/>
+        </p:nvSpPr>
+        <p:spPr>
+          <a:xfrm>
+            <a:off x="8412480" y="2359152"/>
+            <a:ext cx="457200" cy="457200"/>
           </a:xfrm>
           <a:prstGeom prst="rect">
             <a:avLst/>
@@ -11007,7 +10686,7 @@
           <a:p>
             <a:pPr algn="ctr"/>
             <a:r>
-              <a:rPr sz="2000" b="1" i="0">
+              <a:rPr sz="1800" b="1" i="0">
                 <a:solidFill>
                   <a:srgbClr val="FFFFFF"/>
                 </a:solidFill>
@@ -11020,14 +10699,14 @@
       </p:sp>
       <p:sp>
         <p:nvSpPr>
-          <p:cNvPr id="14" name="TextBox 13"/>
-          <p:cNvSpPr txBox="1"/>
-          <p:nvPr/>
-        </p:nvSpPr>
-        <p:spPr>
-          <a:xfrm>
-            <a:off x="1554480" y="4709160"/>
-            <a:ext cx="10058400" cy="548640"/>
+          <p:cNvPr id="26" name="TextBox 25"/>
+          <p:cNvSpPr txBox="1"/>
+          <p:nvPr/>
+        </p:nvSpPr>
+        <p:spPr>
+          <a:xfrm>
+            <a:off x="9006840" y="2331720"/>
+            <a:ext cx="2743200" cy="548640"/>
           </a:xfrm>
           <a:prstGeom prst="rect">
             <a:avLst/>
@@ -11042,27 +10721,27 @@
           <a:p>
             <a:pPr algn="l"/>
             <a:r>
-              <a:rPr sz="2400" b="1" i="0">
+              <a:rPr sz="1400" b="1" i="0">
                 <a:solidFill>
                   <a:srgbClr val="1A1A2E"/>
                 </a:solidFill>
                 <a:latin typeface="Helvetica"/>
               </a:rPr>
-              <a:t>Modest but real</a:t>
-            </a:r>
-          </a:p>
-        </p:txBody>
-      </p:sp>
-      <p:sp>
-        <p:nvSpPr>
-          <p:cNvPr id="15" name="TextBox 14"/>
-          <p:cNvSpPr txBox="1"/>
-          <p:nvPr/>
-        </p:nvSpPr>
-        <p:spPr>
-          <a:xfrm>
-            <a:off x="1554480" y="5303520"/>
-            <a:ext cx="10058400" cy="548640"/>
+              <a:t>Knowledge distillation</a:t>
+            </a:r>
+          </a:p>
+        </p:txBody>
+      </p:sp>
+      <p:sp>
+        <p:nvSpPr>
+          <p:cNvPr id="27" name="TextBox 26"/>
+          <p:cNvSpPr txBox="1"/>
+          <p:nvPr/>
+        </p:nvSpPr>
+        <p:spPr>
+          <a:xfrm>
+            <a:off x="8412480" y="2971800"/>
+            <a:ext cx="3291840" cy="365760"/>
           </a:xfrm>
           <a:prstGeom prst="rect">
             <a:avLst/>
@@ -11077,20 +10756,195 @@
           <a:p>
             <a:pPr algn="l"/>
             <a:r>
-              <a:rPr sz="1500" b="0" i="1">
-                <a:solidFill>
-                  <a:srgbClr val="666677"/>
-                </a:solidFill>
-                <a:latin typeface="Helvetica"/>
-              </a:rPr>
-              <a:t>Consistent across metrics; reproducible from the same checkpoint.</a:t>
-            </a:r>
-          </a:p>
-        </p:txBody>
-      </p:sp>
-      <p:sp>
-        <p:nvSpPr>
-          <p:cNvPr id="16" name="TextBox 15"/>
+              <a:rPr sz="1000" b="1" i="1">
+                <a:solidFill>
+                  <a:srgbClr val="1F6FEB"/>
+                </a:solidFill>
+                <a:latin typeface="Helvetica"/>
+              </a:rPr>
+              <a:t>principled</a:t>
+            </a:r>
+          </a:p>
+        </p:txBody>
+      </p:sp>
+      <p:sp>
+        <p:nvSpPr>
+          <p:cNvPr id="28" name="TextBox 27"/>
+          <p:cNvSpPr txBox="1"/>
+          <p:nvPr/>
+        </p:nvSpPr>
+        <p:spPr>
+          <a:xfrm>
+            <a:off x="8412480" y="3429000"/>
+            <a:ext cx="3291840" cy="365760"/>
+          </a:xfrm>
+          <a:prstGeom prst="rect">
+            <a:avLst/>
+          </a:prstGeom>
+          <a:noFill/>
+        </p:spPr>
+        <p:txBody>
+          <a:bodyPr wrap="square" lIns="0" rIns="0" tIns="0" bIns="0" anchor="t">
+            <a:spAutoFit/>
+          </a:bodyPr>
+          <a:lstStyle/>
+          <a:p>
+            <a:pPr algn="l"/>
+            <a:r>
+              <a:rPr sz="1100" b="1" i="0">
+                <a:solidFill>
+                  <a:srgbClr val="1F6FEB"/>
+                </a:solidFill>
+                <a:latin typeface="Helvetica"/>
+              </a:rPr>
+              <a:t>How</a:t>
+            </a:r>
+          </a:p>
+        </p:txBody>
+      </p:sp>
+      <p:sp>
+        <p:nvSpPr>
+          <p:cNvPr id="29" name="TextBox 28"/>
+          <p:cNvSpPr txBox="1"/>
+          <p:nvPr/>
+        </p:nvSpPr>
+        <p:spPr>
+          <a:xfrm>
+            <a:off x="8412480" y="3749039"/>
+            <a:ext cx="3291840" cy="1280160"/>
+          </a:xfrm>
+          <a:prstGeom prst="rect">
+            <a:avLst/>
+          </a:prstGeom>
+          <a:noFill/>
+        </p:spPr>
+        <p:txBody>
+          <a:bodyPr wrap="square" lIns="0" rIns="0" tIns="0" bIns="0" anchor="t">
+            <a:spAutoFit/>
+          </a:bodyPr>
+          <a:lstStyle/>
+          <a:p>
+            <a:pPr algn="l"/>
+            <a:r>
+              <a:rPr sz="1100" b="0" i="0">
+                <a:solidFill>
+                  <a:srgbClr val="1A1A2E"/>
+                </a:solidFill>
+                <a:latin typeface="Helvetica"/>
+              </a:rPr>
+              <a:t>Transfer v2's small-object improvements into a faster baseline RT-DETR student.</a:t>
+            </a:r>
+          </a:p>
+        </p:txBody>
+      </p:sp>
+      <p:sp>
+        <p:nvSpPr>
+          <p:cNvPr id="30" name="TextBox 29"/>
+          <p:cNvSpPr txBox="1"/>
+          <p:nvPr/>
+        </p:nvSpPr>
+        <p:spPr>
+          <a:xfrm>
+            <a:off x="8412480" y="4846320"/>
+            <a:ext cx="3291840" cy="365760"/>
+          </a:xfrm>
+          <a:prstGeom prst="rect">
+            <a:avLst/>
+          </a:prstGeom>
+          <a:noFill/>
+        </p:spPr>
+        <p:txBody>
+          <a:bodyPr wrap="square" lIns="0" rIns="0" tIns="0" bIns="0" anchor="t">
+            <a:spAutoFit/>
+          </a:bodyPr>
+          <a:lstStyle/>
+          <a:p>
+            <a:pPr algn="l"/>
+            <a:r>
+              <a:rPr sz="1100" b="1" i="0">
+                <a:solidFill>
+                  <a:srgbClr val="2CA02C"/>
+                </a:solidFill>
+                <a:latin typeface="Helvetica"/>
+              </a:rPr>
+              <a:t>Goal</a:t>
+            </a:r>
+          </a:p>
+        </p:txBody>
+      </p:sp>
+      <p:sp>
+        <p:nvSpPr>
+          <p:cNvPr id="31" name="TextBox 30"/>
+          <p:cNvSpPr txBox="1"/>
+          <p:nvPr/>
+        </p:nvSpPr>
+        <p:spPr>
+          <a:xfrm>
+            <a:off x="8412480" y="5166360"/>
+            <a:ext cx="3291840" cy="1280160"/>
+          </a:xfrm>
+          <a:prstGeom prst="rect">
+            <a:avLst/>
+          </a:prstGeom>
+          <a:noFill/>
+        </p:spPr>
+        <p:txBody>
+          <a:bodyPr wrap="square" lIns="0" rIns="0" tIns="0" bIns="0" anchor="t">
+            <a:spAutoFit/>
+          </a:bodyPr>
+          <a:lstStyle/>
+          <a:p>
+            <a:pPr algn="l"/>
+            <a:r>
+              <a:rPr sz="1100" b="0" i="0">
+                <a:solidFill>
+                  <a:srgbClr val="1A1A2E"/>
+                </a:solidFill>
+                <a:latin typeface="Helvetica"/>
+              </a:rPr>
+              <a:t>Recover baseline inference speed while retaining the small-object AP gains learned from P2 feedback.</a:t>
+            </a:r>
+          </a:p>
+        </p:txBody>
+      </p:sp>
+      <p:sp>
+        <p:nvSpPr>
+          <p:cNvPr id="32" name="TextBox 31"/>
+          <p:cNvSpPr txBox="1"/>
+          <p:nvPr/>
+        </p:nvSpPr>
+        <p:spPr>
+          <a:xfrm>
+            <a:off x="640080" y="6126480"/>
+            <a:ext cx="10972800" cy="365760"/>
+          </a:xfrm>
+          <a:prstGeom prst="rect">
+            <a:avLst/>
+          </a:prstGeom>
+          <a:noFill/>
+        </p:spPr>
+        <p:txBody>
+          <a:bodyPr wrap="square" lIns="0" rIns="0" tIns="0" bIns="0" anchor="t">
+            <a:spAutoFit/>
+          </a:bodyPr>
+          <a:lstStyle/>
+          <a:p>
+            <a:pPr algn="ctr"/>
+            <a:r>
+              <a:rPr sz="1300" b="1" i="0">
+                <a:solidFill>
+                  <a:srgbClr val="1F6FEB"/>
+                </a:solidFill>
+                <a:latin typeface="Helvetica"/>
+              </a:rPr>
+              <a:t>Common goal: keep the +0.99 small-object AP gain while approaching the 53 FPS baseline.</a:t>
+            </a:r>
+          </a:p>
+        </p:txBody>
+      </p:sp>
+      <p:sp>
+        <p:nvSpPr>
+          <p:cNvPr id="33" name="TextBox 32"/>
           <p:cNvSpPr txBox="1"/>
           <p:nvPr/>
         </p:nvSpPr>
@@ -11125,7 +10979,7 @@
       </p:sp>
       <p:sp>
         <p:nvSpPr>
-          <p:cNvPr id="17" name="TextBox 16"/>
+          <p:cNvPr id="34" name="TextBox 33"/>
           <p:cNvSpPr txBox="1"/>
           <p:nvPr/>
         </p:nvSpPr>
@@ -11153,7 +11007,7 @@
                 </a:solidFill>
                 <a:latin typeface="Helvetica"/>
               </a:rPr>
-              <a:t>25 / 27</a:t>
+              <a:t>25 / 28</a:t>
             </a:r>
           </a:p>
         </p:txBody>
@@ -11184,6 +11038,616 @@
         </p:nvSpPr>
         <p:spPr>
           <a:xfrm>
+            <a:off x="640080" y="457200"/>
+            <a:ext cx="10972800" cy="822960"/>
+          </a:xfrm>
+          <a:prstGeom prst="rect">
+            <a:avLst/>
+          </a:prstGeom>
+          <a:noFill/>
+        </p:spPr>
+        <p:txBody>
+          <a:bodyPr wrap="square" lIns="0" rIns="0" tIns="0" bIns="0" anchor="t">
+            <a:spAutoFit/>
+          </a:bodyPr>
+          <a:lstStyle/>
+          <a:p>
+            <a:pPr algn="l"/>
+            <a:r>
+              <a:rPr sz="3400" b="1" i="0">
+                <a:solidFill>
+                  <a:srgbClr val="1F6FEB"/>
+                </a:solidFill>
+                <a:latin typeface="Helvetica"/>
+              </a:rPr>
+              <a:t>Conclusion</a:t>
+            </a:r>
+          </a:p>
+        </p:txBody>
+      </p:sp>
+      <p:sp>
+        <p:nvSpPr>
+          <p:cNvPr id="3" name="Rectangle 2"/>
+          <p:cNvSpPr/>
+          <p:nvPr/>
+        </p:nvSpPr>
+        <p:spPr>
+          <a:xfrm>
+            <a:off x="640080" y="1143000"/>
+            <a:ext cx="640080" cy="54864"/>
+          </a:xfrm>
+          <a:prstGeom prst="rect">
+            <a:avLst/>
+          </a:prstGeom>
+          <a:solidFill>
+            <a:srgbClr val="1F6FEB"/>
+          </a:solidFill>
+          <a:ln>
+            <a:noFill/>
+          </a:ln>
+        </p:spPr>
+        <p:style>
+          <a:lnRef idx="1">
+            <a:schemeClr val="accent1"/>
+          </a:lnRef>
+          <a:fillRef idx="3">
+            <a:schemeClr val="accent1"/>
+          </a:fillRef>
+          <a:effectRef idx="2">
+            <a:schemeClr val="accent1"/>
+          </a:effectRef>
+          <a:fontRef idx="minor">
+            <a:schemeClr val="lt1"/>
+          </a:fontRef>
+        </p:style>
+        <p:txBody>
+          <a:bodyPr rtlCol="0" anchor="ctr"/>
+          <a:lstStyle/>
+          <a:p>
+            <a:pPr algn="ctr"/>
+          </a:p>
+        </p:txBody>
+      </p:sp>
+      <p:sp>
+        <p:nvSpPr>
+          <p:cNvPr id="4" name="Oval 3"/>
+          <p:cNvSpPr/>
+          <p:nvPr/>
+        </p:nvSpPr>
+        <p:spPr>
+          <a:xfrm>
+            <a:off x="822960" y="1965960"/>
+            <a:ext cx="502920" cy="502920"/>
+          </a:xfrm>
+          <a:prstGeom prst="ellipse">
+            <a:avLst/>
+          </a:prstGeom>
+          <a:solidFill>
+            <a:srgbClr val="1F6FEB"/>
+          </a:solidFill>
+          <a:ln>
+            <a:noFill/>
+          </a:ln>
+        </p:spPr>
+        <p:style>
+          <a:lnRef idx="1">
+            <a:schemeClr val="accent1"/>
+          </a:lnRef>
+          <a:fillRef idx="3">
+            <a:schemeClr val="accent1"/>
+          </a:fillRef>
+          <a:effectRef idx="2">
+            <a:schemeClr val="accent1"/>
+          </a:effectRef>
+          <a:fontRef idx="minor">
+            <a:schemeClr val="lt1"/>
+          </a:fontRef>
+        </p:style>
+        <p:txBody>
+          <a:bodyPr rtlCol="0" anchor="ctr"/>
+          <a:lstStyle/>
+          <a:p>
+            <a:pPr algn="ctr"/>
+          </a:p>
+        </p:txBody>
+      </p:sp>
+      <p:sp>
+        <p:nvSpPr>
+          <p:cNvPr id="5" name="TextBox 4"/>
+          <p:cNvSpPr txBox="1"/>
+          <p:nvPr/>
+        </p:nvSpPr>
+        <p:spPr>
+          <a:xfrm>
+            <a:off x="822960" y="1993392"/>
+            <a:ext cx="502920" cy="502920"/>
+          </a:xfrm>
+          <a:prstGeom prst="rect">
+            <a:avLst/>
+          </a:prstGeom>
+          <a:noFill/>
+        </p:spPr>
+        <p:txBody>
+          <a:bodyPr wrap="square" lIns="0" rIns="0" tIns="0" bIns="0" anchor="t">
+            <a:spAutoFit/>
+          </a:bodyPr>
+          <a:lstStyle/>
+          <a:p>
+            <a:pPr algn="ctr"/>
+            <a:r>
+              <a:rPr sz="2000" b="1" i="0">
+                <a:solidFill>
+                  <a:srgbClr val="FFFFFF"/>
+                </a:solidFill>
+                <a:latin typeface="Helvetica"/>
+              </a:rPr>
+              <a:t>1</a:t>
+            </a:r>
+          </a:p>
+        </p:txBody>
+      </p:sp>
+      <p:sp>
+        <p:nvSpPr>
+          <p:cNvPr id="6" name="TextBox 5"/>
+          <p:cNvSpPr txBox="1"/>
+          <p:nvPr/>
+        </p:nvSpPr>
+        <p:spPr>
+          <a:xfrm>
+            <a:off x="1554480" y="1874520"/>
+            <a:ext cx="10058400" cy="548640"/>
+          </a:xfrm>
+          <a:prstGeom prst="rect">
+            <a:avLst/>
+          </a:prstGeom>
+          <a:noFill/>
+        </p:spPr>
+        <p:txBody>
+          <a:bodyPr wrap="square" lIns="0" rIns="0" tIns="0" bIns="0" anchor="t">
+            <a:spAutoFit/>
+          </a:bodyPr>
+          <a:lstStyle/>
+          <a:p>
+            <a:pPr algn="l"/>
+            <a:r>
+              <a:rPr sz="2400" b="1" i="0">
+                <a:solidFill>
+                  <a:srgbClr val="1A1A2E"/>
+                </a:solidFill>
+                <a:latin typeface="Helvetica"/>
+              </a:rPr>
+              <a:t>Feedback improves small-object detection</a:t>
+            </a:r>
+          </a:p>
+        </p:txBody>
+      </p:sp>
+      <p:sp>
+        <p:nvSpPr>
+          <p:cNvPr id="7" name="TextBox 6"/>
+          <p:cNvSpPr txBox="1"/>
+          <p:nvPr/>
+        </p:nvSpPr>
+        <p:spPr>
+          <a:xfrm>
+            <a:off x="1554480" y="2468880"/>
+            <a:ext cx="10058400" cy="548640"/>
+          </a:xfrm>
+          <a:prstGeom prst="rect">
+            <a:avLst/>
+          </a:prstGeom>
+          <a:noFill/>
+        </p:spPr>
+        <p:txBody>
+          <a:bodyPr wrap="square" lIns="0" rIns="0" tIns="0" bIns="0" anchor="t">
+            <a:spAutoFit/>
+          </a:bodyPr>
+          <a:lstStyle/>
+          <a:p>
+            <a:pPr algn="l"/>
+            <a:r>
+              <a:rPr sz="1500" b="0" i="1">
+                <a:solidFill>
+                  <a:srgbClr val="666677"/>
+                </a:solidFill>
+                <a:latin typeface="Helvetica"/>
+              </a:rPr>
+              <a:t>+0.99 small-object AP, causal contribution at inference.</a:t>
+            </a:r>
+          </a:p>
+        </p:txBody>
+      </p:sp>
+      <p:sp>
+        <p:nvSpPr>
+          <p:cNvPr id="8" name="Oval 7"/>
+          <p:cNvSpPr/>
+          <p:nvPr/>
+        </p:nvSpPr>
+        <p:spPr>
+          <a:xfrm>
+            <a:off x="822960" y="3383280"/>
+            <a:ext cx="502920" cy="502920"/>
+          </a:xfrm>
+          <a:prstGeom prst="ellipse">
+            <a:avLst/>
+          </a:prstGeom>
+          <a:solidFill>
+            <a:srgbClr val="1F6FEB"/>
+          </a:solidFill>
+          <a:ln>
+            <a:noFill/>
+          </a:ln>
+        </p:spPr>
+        <p:style>
+          <a:lnRef idx="1">
+            <a:schemeClr val="accent1"/>
+          </a:lnRef>
+          <a:fillRef idx="3">
+            <a:schemeClr val="accent1"/>
+          </a:fillRef>
+          <a:effectRef idx="2">
+            <a:schemeClr val="accent1"/>
+          </a:effectRef>
+          <a:fontRef idx="minor">
+            <a:schemeClr val="lt1"/>
+          </a:fontRef>
+        </p:style>
+        <p:txBody>
+          <a:bodyPr rtlCol="0" anchor="ctr"/>
+          <a:lstStyle/>
+          <a:p>
+            <a:pPr algn="ctr"/>
+          </a:p>
+        </p:txBody>
+      </p:sp>
+      <p:sp>
+        <p:nvSpPr>
+          <p:cNvPr id="9" name="TextBox 8"/>
+          <p:cNvSpPr txBox="1"/>
+          <p:nvPr/>
+        </p:nvSpPr>
+        <p:spPr>
+          <a:xfrm>
+            <a:off x="822960" y="3410712"/>
+            <a:ext cx="502920" cy="502920"/>
+          </a:xfrm>
+          <a:prstGeom prst="rect">
+            <a:avLst/>
+          </a:prstGeom>
+          <a:noFill/>
+        </p:spPr>
+        <p:txBody>
+          <a:bodyPr wrap="square" lIns="0" rIns="0" tIns="0" bIns="0" anchor="t">
+            <a:spAutoFit/>
+          </a:bodyPr>
+          <a:lstStyle/>
+          <a:p>
+            <a:pPr algn="ctr"/>
+            <a:r>
+              <a:rPr sz="2000" b="1" i="0">
+                <a:solidFill>
+                  <a:srgbClr val="FFFFFF"/>
+                </a:solidFill>
+                <a:latin typeface="Helvetica"/>
+              </a:rPr>
+              <a:t>2</a:t>
+            </a:r>
+          </a:p>
+        </p:txBody>
+      </p:sp>
+      <p:sp>
+        <p:nvSpPr>
+          <p:cNvPr id="10" name="TextBox 9"/>
+          <p:cNvSpPr txBox="1"/>
+          <p:nvPr/>
+        </p:nvSpPr>
+        <p:spPr>
+          <a:xfrm>
+            <a:off x="1554480" y="3291840"/>
+            <a:ext cx="10058400" cy="548640"/>
+          </a:xfrm>
+          <a:prstGeom prst="rect">
+            <a:avLst/>
+          </a:prstGeom>
+          <a:noFill/>
+        </p:spPr>
+        <p:txBody>
+          <a:bodyPr wrap="square" lIns="0" rIns="0" tIns="0" bIns="0" anchor="t">
+            <a:spAutoFit/>
+          </a:bodyPr>
+          <a:lstStyle/>
+          <a:p>
+            <a:pPr algn="l"/>
+            <a:r>
+              <a:rPr sz="2400" b="1" i="0">
+                <a:solidFill>
+                  <a:srgbClr val="1A1A2E"/>
+                </a:solidFill>
+                <a:latin typeface="Helvetica"/>
+              </a:rPr>
+              <a:t>Only works with proper design</a:t>
+            </a:r>
+          </a:p>
+        </p:txBody>
+      </p:sp>
+      <p:sp>
+        <p:nvSpPr>
+          <p:cNvPr id="11" name="TextBox 10"/>
+          <p:cNvSpPr txBox="1"/>
+          <p:nvPr/>
+        </p:nvSpPr>
+        <p:spPr>
+          <a:xfrm>
+            <a:off x="1554480" y="3886200"/>
+            <a:ext cx="10058400" cy="548640"/>
+          </a:xfrm>
+          <a:prstGeom prst="rect">
+            <a:avLst/>
+          </a:prstGeom>
+          <a:noFill/>
+        </p:spPr>
+        <p:txBody>
+          <a:bodyPr wrap="square" lIns="0" rIns="0" tIns="0" bIns="0" anchor="t">
+            <a:spAutoFit/>
+          </a:bodyPr>
+          <a:lstStyle/>
+          <a:p>
+            <a:pPr algn="l"/>
+            <a:r>
+              <a:rPr sz="1500" b="0" i="1">
+                <a:solidFill>
+                  <a:srgbClr val="666677"/>
+                </a:solidFill>
+                <a:latin typeface="Helvetica"/>
+              </a:rPr>
+              <a:t>Floor the gate; restrict to small-object levels.</a:t>
+            </a:r>
+          </a:p>
+        </p:txBody>
+      </p:sp>
+      <p:sp>
+        <p:nvSpPr>
+          <p:cNvPr id="12" name="Oval 11"/>
+          <p:cNvSpPr/>
+          <p:nvPr/>
+        </p:nvSpPr>
+        <p:spPr>
+          <a:xfrm>
+            <a:off x="822960" y="4800600"/>
+            <a:ext cx="502920" cy="502920"/>
+          </a:xfrm>
+          <a:prstGeom prst="ellipse">
+            <a:avLst/>
+          </a:prstGeom>
+          <a:solidFill>
+            <a:srgbClr val="1F6FEB"/>
+          </a:solidFill>
+          <a:ln>
+            <a:noFill/>
+          </a:ln>
+        </p:spPr>
+        <p:style>
+          <a:lnRef idx="1">
+            <a:schemeClr val="accent1"/>
+          </a:lnRef>
+          <a:fillRef idx="3">
+            <a:schemeClr val="accent1"/>
+          </a:fillRef>
+          <a:effectRef idx="2">
+            <a:schemeClr val="accent1"/>
+          </a:effectRef>
+          <a:fontRef idx="minor">
+            <a:schemeClr val="lt1"/>
+          </a:fontRef>
+        </p:style>
+        <p:txBody>
+          <a:bodyPr rtlCol="0" anchor="ctr"/>
+          <a:lstStyle/>
+          <a:p>
+            <a:pPr algn="ctr"/>
+          </a:p>
+        </p:txBody>
+      </p:sp>
+      <p:sp>
+        <p:nvSpPr>
+          <p:cNvPr id="13" name="TextBox 12"/>
+          <p:cNvSpPr txBox="1"/>
+          <p:nvPr/>
+        </p:nvSpPr>
+        <p:spPr>
+          <a:xfrm>
+            <a:off x="822960" y="4828032"/>
+            <a:ext cx="502920" cy="502920"/>
+          </a:xfrm>
+          <a:prstGeom prst="rect">
+            <a:avLst/>
+          </a:prstGeom>
+          <a:noFill/>
+        </p:spPr>
+        <p:txBody>
+          <a:bodyPr wrap="square" lIns="0" rIns="0" tIns="0" bIns="0" anchor="t">
+            <a:spAutoFit/>
+          </a:bodyPr>
+          <a:lstStyle/>
+          <a:p>
+            <a:pPr algn="ctr"/>
+            <a:r>
+              <a:rPr sz="2000" b="1" i="0">
+                <a:solidFill>
+                  <a:srgbClr val="FFFFFF"/>
+                </a:solidFill>
+                <a:latin typeface="Helvetica"/>
+              </a:rPr>
+              <a:t>3</a:t>
+            </a:r>
+          </a:p>
+        </p:txBody>
+      </p:sp>
+      <p:sp>
+        <p:nvSpPr>
+          <p:cNvPr id="14" name="TextBox 13"/>
+          <p:cNvSpPr txBox="1"/>
+          <p:nvPr/>
+        </p:nvSpPr>
+        <p:spPr>
+          <a:xfrm>
+            <a:off x="1554480" y="4709160"/>
+            <a:ext cx="10058400" cy="548640"/>
+          </a:xfrm>
+          <a:prstGeom prst="rect">
+            <a:avLst/>
+          </a:prstGeom>
+          <a:noFill/>
+        </p:spPr>
+        <p:txBody>
+          <a:bodyPr wrap="square" lIns="0" rIns="0" tIns="0" bIns="0" anchor="t">
+            <a:spAutoFit/>
+          </a:bodyPr>
+          <a:lstStyle/>
+          <a:p>
+            <a:pPr algn="l"/>
+            <a:r>
+              <a:rPr sz="2400" b="1" i="0">
+                <a:solidFill>
+                  <a:srgbClr val="1A1A2E"/>
+                </a:solidFill>
+                <a:latin typeface="Helvetica"/>
+              </a:rPr>
+              <a:t>Modest but real</a:t>
+            </a:r>
+          </a:p>
+        </p:txBody>
+      </p:sp>
+      <p:sp>
+        <p:nvSpPr>
+          <p:cNvPr id="15" name="TextBox 14"/>
+          <p:cNvSpPr txBox="1"/>
+          <p:nvPr/>
+        </p:nvSpPr>
+        <p:spPr>
+          <a:xfrm>
+            <a:off x="1554480" y="5303520"/>
+            <a:ext cx="10058400" cy="548640"/>
+          </a:xfrm>
+          <a:prstGeom prst="rect">
+            <a:avLst/>
+          </a:prstGeom>
+          <a:noFill/>
+        </p:spPr>
+        <p:txBody>
+          <a:bodyPr wrap="square" lIns="0" rIns="0" tIns="0" bIns="0" anchor="t">
+            <a:spAutoFit/>
+          </a:bodyPr>
+          <a:lstStyle/>
+          <a:p>
+            <a:pPr algn="l"/>
+            <a:r>
+              <a:rPr sz="1500" b="0" i="1">
+                <a:solidFill>
+                  <a:srgbClr val="666677"/>
+                </a:solidFill>
+                <a:latin typeface="Helvetica"/>
+              </a:rPr>
+              <a:t>Consistent across metrics; reproducible from the same checkpoint.</a:t>
+            </a:r>
+          </a:p>
+        </p:txBody>
+      </p:sp>
+      <p:sp>
+        <p:nvSpPr>
+          <p:cNvPr id="16" name="TextBox 15"/>
+          <p:cNvSpPr txBox="1"/>
+          <p:nvPr/>
+        </p:nvSpPr>
+        <p:spPr>
+          <a:xfrm>
+            <a:off x="640080" y="6446520"/>
+            <a:ext cx="9144000" cy="274320"/>
+          </a:xfrm>
+          <a:prstGeom prst="rect">
+            <a:avLst/>
+          </a:prstGeom>
+          <a:noFill/>
+        </p:spPr>
+        <p:txBody>
+          <a:bodyPr wrap="square" lIns="0" rIns="0" tIns="0" bIns="0" anchor="t">
+            <a:spAutoFit/>
+          </a:bodyPr>
+          <a:lstStyle/>
+          <a:p>
+            <a:pPr algn="l"/>
+            <a:r>
+              <a:rPr sz="1000" b="0" i="0">
+                <a:solidFill>
+                  <a:srgbClr val="666677"/>
+                </a:solidFill>
+                <a:latin typeface="Helvetica"/>
+              </a:rPr>
+              <a:t>5. Final Results  •  Feedback-Augmented RT-DETR  •  Hatem Saadallah &amp; Nour Jennane</a:t>
+            </a:r>
+          </a:p>
+        </p:txBody>
+      </p:sp>
+      <p:sp>
+        <p:nvSpPr>
+          <p:cNvPr id="17" name="TextBox 16"/>
+          <p:cNvSpPr txBox="1"/>
+          <p:nvPr/>
+        </p:nvSpPr>
+        <p:spPr>
+          <a:xfrm>
+            <a:off x="10515600" y="6446520"/>
+            <a:ext cx="1097280" cy="274320"/>
+          </a:xfrm>
+          <a:prstGeom prst="rect">
+            <a:avLst/>
+          </a:prstGeom>
+          <a:noFill/>
+        </p:spPr>
+        <p:txBody>
+          <a:bodyPr wrap="square" lIns="0" rIns="0" tIns="0" bIns="0" anchor="t">
+            <a:spAutoFit/>
+          </a:bodyPr>
+          <a:lstStyle/>
+          <a:p>
+            <a:pPr algn="r"/>
+            <a:r>
+              <a:rPr sz="1000" b="0" i="0">
+                <a:solidFill>
+                  <a:srgbClr val="666677"/>
+                </a:solidFill>
+                <a:latin typeface="Helvetica"/>
+              </a:rPr>
+              <a:t>26 / 28</a:t>
+            </a:r>
+          </a:p>
+        </p:txBody>
+      </p:sp>
+    </p:spTree>
+  </p:cSld>
+  <p:clrMapOvr>
+    <a:masterClrMapping/>
+  </p:clrMapOvr>
+</p:sld>
+</file>
+
+<file path=ppt/slides/slide28.xml><?xml version="1.0" encoding="utf-8"?>
+<p:sld xmlns:a="http://schemas.openxmlformats.org/drawingml/2006/main" xmlns:p="http://schemas.openxmlformats.org/presentationml/2006/main" xmlns:r="http://schemas.openxmlformats.org/officeDocument/2006/relationships">
+  <p:cSld>
+    <p:spTree>
+      <p:nvGrpSpPr>
+        <p:cNvPr id="1" name=""/>
+        <p:cNvGrpSpPr/>
+        <p:nvPr/>
+      </p:nvGrpSpPr>
+      <p:grpSpPr/>
+      <p:sp>
+        <p:nvSpPr>
+          <p:cNvPr id="2" name="TextBox 1"/>
+          <p:cNvSpPr txBox="1"/>
+          <p:nvPr/>
+        </p:nvSpPr>
+        <p:spPr>
+          <a:xfrm>
             <a:off x="640080" y="2194560"/>
             <a:ext cx="10972800" cy="1371600"/>
           </a:xfrm>
@@ -11755,7 +12219,7 @@
                 </a:solidFill>
                 <a:latin typeface="Helvetica"/>
               </a:rPr>
-              <a:t>2 / 27</a:t>
+              <a:t>2 / 28</a:t>
             </a:r>
           </a:p>
         </p:txBody>
@@ -12015,7 +12479,7 @@
                 </a:solidFill>
                 <a:latin typeface="Helvetica"/>
               </a:rPr>
-              <a:t>3 / 27</a:t>
+              <a:t>3 / 28</a:t>
             </a:r>
           </a:p>
         </p:txBody>
@@ -12275,7 +12739,7 @@
                 </a:solidFill>
                 <a:latin typeface="Helvetica"/>
               </a:rPr>
-              <a:t>4 / 27</a:t>
+              <a:t>4 / 28</a:t>
             </a:r>
           </a:p>
         </p:txBody>
@@ -12511,7 +12975,7 @@
                 </a:solidFill>
                 <a:latin typeface="Helvetica"/>
               </a:rPr>
-              <a:t>5 / 27</a:t>
+              <a:t>5 / 28</a:t>
             </a:r>
           </a:p>
         </p:txBody>
@@ -13189,7 +13653,7 @@
                 </a:solidFill>
                 <a:latin typeface="Helvetica"/>
               </a:rPr>
-              <a:t>6 / 27</a:t>
+              <a:t>6 / 28</a:t>
             </a:r>
           </a:p>
         </p:txBody>
@@ -13425,7 +13889,7 @@
                 </a:solidFill>
                 <a:latin typeface="Helvetica"/>
               </a:rPr>
-              <a:t>7 / 27</a:t>
+              <a:t>7 / 28</a:t>
             </a:r>
           </a:p>
         </p:txBody>
@@ -13650,7 +14114,7 @@
                 </a:solidFill>
                 <a:latin typeface="Helvetica"/>
               </a:rPr>
-              <a:t>8 / 27</a:t>
+              <a:t>8 / 28</a:t>
             </a:r>
           </a:p>
         </p:txBody>

</xml_diff>